<commit_message>
feat/ se añadieron los puntos 1, 2 y 3 de SOA y PatronesDiseño
</commit_message>
<xml_diff>
--- a/SOA_Observer_Mediator_estructura_separada.pptx
+++ b/SOA_Observer_Mediator_estructura_separada.pptx
@@ -4,6 +4,9 @@
   <p:sldMasterIdLst>
     <p:sldMasterId id="2147483648" r:id="rId1"/>
   </p:sldMasterIdLst>
+  <p:notesMasterIdLst>
+    <p:notesMasterId r:id="rId10"/>
+  </p:notesMasterIdLst>
   <p:sldIdLst>
     <p:sldId id="256" r:id="rId2"/>
     <p:sldId id="257" r:id="rId3"/>
@@ -14,10 +17,7 @@
     <p:sldId id="262" r:id="rId8"/>
     <p:sldId id="263" r:id="rId9"/>
   </p:sldIdLst>
-  <p:notesMasterIdLst>
-    <p:notesMasterId r:id="rId10"/>
-  </p:notesMasterIdLst>
-  <p:sldSz cx="9144000" cy="5143500"/>
+  <p:sldSz cx="9144000" cy="5143500" type="screen16x9"/>
   <p:notesSz cx="5143500" cy="9144000"/>
   <p:defaultTextStyle>
     <a:lvl1pPr marL="0" algn="l" defTabSz="914400" rtl="0" eaLnBrk="1" latinLnBrk="0" hangingPunct="1">
@@ -111,6 +111,11 @@
       </a:defRPr>
     </a:lvl9pPr>
   </p:defaultTextStyle>
+  <p:extLst>
+    <p:ext uri="{EFAFB233-063F-42B5-8137-9DF3F51BA10A}">
+      <p15:sldGuideLst xmlns:p15="http://schemas.microsoft.com/office/powerpoint/2012/main"/>
+    </p:ext>
+  </p:extLst>
 </p:presentation>
 </file>
 
@@ -136,234 +141,10 @@
           <a:chExt cx="0" cy="0"/>
         </a:xfrm>
       </p:grpSpPr>
-      <p:sp>
-        <p:nvSpPr>
-          <p:cNvPr id="2" name="Header Placeholder 1"/>
-          <p:cNvSpPr>
-            <a:spLocks noGrp="1"/>
-          </p:cNvSpPr>
-          <p:nvPr>
-            <p:ph type="hdr" sz="quarter"/>
-          </p:nvPr>
-        </p:nvSpPr>
-        <p:spPr>
-          <a:xfrm>
-            <a:off x="0" y="0"/>
-            <a:ext cx="2971800" cy="458788"/>
-          </a:xfrm>
-          <a:prstGeom prst="rect">
-            <a:avLst/>
-          </a:prstGeom>
-        </p:spPr>
-        <p:txBody>
-          <a:bodyPr vert="horz" lIns="91440" tIns="45720" rIns="91440" bIns="45720" rtlCol="0"/>
-          <a:lstStyle>
-            <a:lvl1pPr algn="l">
-              <a:defRPr sz="1200"/>
-            </a:lvl1pPr>
-          </a:lstStyle>
-          <a:p>
-            <a:endParaRPr lang="en-US"/>
-          </a:p>
-        </p:txBody>
-      </p:sp>
-      <p:sp>
-        <p:nvSpPr>
-          <p:cNvPr id="3" name="Date Placeholder 2"/>
-          <p:cNvSpPr>
-            <a:spLocks noGrp="1"/>
-          </p:cNvSpPr>
-          <p:nvPr>
-            <p:ph type="dt" idx="1"/>
-          </p:nvPr>
-        </p:nvSpPr>
-        <p:spPr>
-          <a:xfrm>
-            <a:off x="3884613" y="0"/>
-            <a:ext cx="2971800" cy="458788"/>
-          </a:xfrm>
-          <a:prstGeom prst="rect">
-            <a:avLst/>
-          </a:prstGeom>
-        </p:spPr>
-        <p:txBody>
-          <a:bodyPr vert="horz" lIns="91440" tIns="45720" rIns="91440" bIns="45720" rtlCol="0"/>
-          <a:lstStyle>
-            <a:lvl1pPr algn="r">
-              <a:defRPr sz="1200"/>
-            </a:lvl1pPr>
-          </a:lstStyle>
-          <a:p>
-            <a:fld id="{5282F153-3F37-0F45-9E97-73ACFA13230C}" type="datetimeFigureOut">
-              <a:rPr lang="en-US"/>
-              <a:t>7/23/19</a:t>
-            </a:fld>
-            <a:endParaRPr lang="en-US"/>
-          </a:p>
-        </p:txBody>
-      </p:sp>
-      <p:sp>
-        <p:nvSpPr>
-          <p:cNvPr id="4" name="Slide Image Placeholder 3"/>
-          <p:cNvSpPr>
-            <a:spLocks noGrp="1" noRot="1" noChangeAspect="1"/>
-          </p:cNvSpPr>
-          <p:nvPr>
-            <p:ph type="sldImg" idx="2"/>
-          </p:nvPr>
-        </p:nvSpPr>
-        <p:spPr>
-          <a:xfrm>
-            <a:off x="685800" y="1143000"/>
-            <a:ext cx="5486400" cy="3086100"/>
-          </a:xfrm>
-          <a:prstGeom prst="rect">
-            <a:avLst/>
-          </a:prstGeom>
-          <a:noFill/>
-          <a:ln w="12700">
-            <a:solidFill>
-              <a:prstClr val="black"/>
-            </a:solidFill>
-          </a:ln>
-        </p:spPr>
-        <p:txBody>
-          <a:bodyPr vert="horz" lIns="91440" tIns="45720" rIns="91440" bIns="45720" rtlCol="0" anchor="ctr"/>
-          <a:lstStyle/>
-          <a:p>
-            <a:endParaRPr lang="en-US"/>
-          </a:p>
-        </p:txBody>
-      </p:sp>
-      <p:sp>
-        <p:nvSpPr>
-          <p:cNvPr id="5" name="Notes Placeholder 4"/>
-          <p:cNvSpPr>
-            <a:spLocks noGrp="1"/>
-          </p:cNvSpPr>
-          <p:nvPr>
-            <p:ph type="body" sz="quarter" idx="3"/>
-          </p:nvPr>
-        </p:nvSpPr>
-        <p:spPr>
-          <a:xfrm>
-            <a:off x="685800" y="4400550"/>
-            <a:ext cx="5486400" cy="3600450"/>
-          </a:xfrm>
-          <a:prstGeom prst="rect">
-            <a:avLst/>
-          </a:prstGeom>
-        </p:spPr>
-        <p:txBody>
-          <a:bodyPr vert="horz" lIns="91440" tIns="45720" rIns="91440" bIns="45720" rtlCol="0"/>
-          <a:lstStyle/>
-          <a:p>
-            <a:pPr lvl="0"/>
-            <a:r>
-              <a:rPr lang="en-US"/>
-              <a:t>Click to edit Master text styles</a:t>
-            </a:r>
-          </a:p>
-          <a:p>
-            <a:pPr lvl="1"/>
-            <a:r>
-              <a:rPr lang="en-US"/>
-              <a:t>Second level</a:t>
-            </a:r>
-          </a:p>
-          <a:p>
-            <a:pPr lvl="2"/>
-            <a:r>
-              <a:rPr lang="en-US"/>
-              <a:t>Third level</a:t>
-            </a:r>
-          </a:p>
-          <a:p>
-            <a:pPr lvl="3"/>
-            <a:r>
-              <a:rPr lang="en-US"/>
-              <a:t>Fourth level</a:t>
-            </a:r>
-          </a:p>
-          <a:p>
-            <a:pPr lvl="4"/>
-            <a:r>
-              <a:rPr lang="en-US"/>
-              <a:t>Fifth level</a:t>
-            </a:r>
-          </a:p>
-        </p:txBody>
-      </p:sp>
-      <p:sp>
-        <p:nvSpPr>
-          <p:cNvPr id="6" name="Footer Placeholder 5"/>
-          <p:cNvSpPr>
-            <a:spLocks noGrp="1"/>
-          </p:cNvSpPr>
-          <p:nvPr>
-            <p:ph type="ftr" sz="quarter" idx="4"/>
-          </p:nvPr>
-        </p:nvSpPr>
-        <p:spPr>
-          <a:xfrm>
-            <a:off x="0" y="8685213"/>
-            <a:ext cx="2971800" cy="458787"/>
-          </a:xfrm>
-          <a:prstGeom prst="rect">
-            <a:avLst/>
-          </a:prstGeom>
-        </p:spPr>
-        <p:txBody>
-          <a:bodyPr vert="horz" lIns="91440" tIns="45720" rIns="91440" bIns="45720" rtlCol="0" anchor="b"/>
-          <a:lstStyle>
-            <a:lvl1pPr algn="l">
-              <a:defRPr sz="1200"/>
-            </a:lvl1pPr>
-          </a:lstStyle>
-          <a:p>
-            <a:endParaRPr lang="en-US"/>
-          </a:p>
-        </p:txBody>
-      </p:sp>
-      <p:sp>
-        <p:nvSpPr>
-          <p:cNvPr id="7" name="Slide Number Placeholder 6"/>
-          <p:cNvSpPr>
-            <a:spLocks noGrp="1"/>
-          </p:cNvSpPr>
-          <p:nvPr>
-            <p:ph type="sldNum" sz="quarter" idx="5"/>
-          </p:nvPr>
-        </p:nvSpPr>
-        <p:spPr>
-          <a:xfrm>
-            <a:off x="3884613" y="8685213"/>
-            <a:ext cx="2971800" cy="458787"/>
-          </a:xfrm>
-          <a:prstGeom prst="rect">
-            <a:avLst/>
-          </a:prstGeom>
-        </p:spPr>
-        <p:txBody>
-          <a:bodyPr vert="horz" lIns="91440" tIns="45720" rIns="91440" bIns="45720" rtlCol="0" anchor="b"/>
-          <a:lstStyle>
-            <a:lvl1pPr algn="r">
-              <a:defRPr sz="1200"/>
-            </a:lvl1pPr>
-          </a:lstStyle>
-          <a:p>
-            <a:fld id="{CE5E9CC1-C706-0F49-92D6-E571CC5EEA8F}" type="slidenum">
-              <a:rPr lang="en-US"/>
-              <a:t>‹#›</a:t>
-            </a:fld>
-            <a:endParaRPr lang="en-US"/>
-          </a:p>
-        </p:txBody>
-      </p:sp>
     </p:spTree>
     <p:extLst>
       <p:ext uri="{BB962C8B-B14F-4D97-AF65-F5344CB8AC3E}">
-        <p14:creationId xmlns:p14="http://schemas.microsoft.com/office/powerpoint/2010/main" val="1024086991"/>
+        <p14:creationId xmlns:p14="http://schemas.microsoft.com/office/powerpoint/2010/main" val="21680797"/>
       </p:ext>
     </p:extLst>
   </p:cSld>
@@ -507,10 +288,6 @@
           <a:bodyPr/>
           <a:lstStyle/>
           <a:p>
-            <a:r>
-              <a:rPr lang="en-US" dirty="0"/>
-              <a:t/>
-            </a:r>
             <a:endParaRPr lang="en-US" dirty="0"/>
           </a:p>
         </p:txBody>
@@ -595,10 +372,6 @@
           <a:bodyPr/>
           <a:lstStyle/>
           <a:p>
-            <a:r>
-              <a:rPr lang="en-US" dirty="0"/>
-              <a:t/>
-            </a:r>
             <a:endParaRPr lang="en-US" dirty="0"/>
           </a:p>
         </p:txBody>
@@ -683,10 +456,6 @@
           <a:bodyPr/>
           <a:lstStyle/>
           <a:p>
-            <a:r>
-              <a:rPr lang="en-US" dirty="0"/>
-              <a:t/>
-            </a:r>
             <a:endParaRPr lang="en-US" dirty="0"/>
           </a:p>
         </p:txBody>
@@ -771,10 +540,6 @@
           <a:bodyPr/>
           <a:lstStyle/>
           <a:p>
-            <a:r>
-              <a:rPr lang="en-US" dirty="0"/>
-              <a:t/>
-            </a:r>
             <a:endParaRPr lang="en-US" dirty="0"/>
           </a:p>
         </p:txBody>
@@ -859,10 +624,6 @@
           <a:bodyPr/>
           <a:lstStyle/>
           <a:p>
-            <a:r>
-              <a:rPr lang="en-US" dirty="0"/>
-              <a:t/>
-            </a:r>
             <a:endParaRPr lang="en-US" dirty="0"/>
           </a:p>
         </p:txBody>
@@ -947,10 +708,6 @@
           <a:bodyPr/>
           <a:lstStyle/>
           <a:p>
-            <a:r>
-              <a:rPr lang="en-US" dirty="0"/>
-              <a:t/>
-            </a:r>
             <a:endParaRPr lang="en-US" dirty="0"/>
           </a:p>
         </p:txBody>
@@ -1035,10 +792,6 @@
           <a:bodyPr/>
           <a:lstStyle/>
           <a:p>
-            <a:r>
-              <a:rPr lang="en-US" dirty="0"/>
-              <a:t/>
-            </a:r>
             <a:endParaRPr lang="en-US" dirty="0"/>
           </a:p>
         </p:txBody>
@@ -1123,10 +876,6 @@
           <a:bodyPr/>
           <a:lstStyle/>
           <a:p>
-            <a:r>
-              <a:rPr lang="en-US" dirty="0"/>
-              <a:t/>
-            </a:r>
             <a:endParaRPr lang="en-US" dirty="0"/>
           </a:p>
         </p:txBody>
@@ -1205,6 +954,7 @@
         <a:solidFill>
           <a:srgbClr val="1F4E9C"/>
         </a:solidFill>
+        <a:effectLst/>
       </p:bgPr>
     </p:bg>
     <p:spTree>
@@ -1224,9 +974,11 @@
       <p:sp>
         <p:nvSpPr>
           <p:cNvPr id="2" name="Text 0"/>
-          <p:cNvSpPr/>
+          <p:cNvSpPr>
+            <a:spLocks noGrp="1"/>
+          </p:cNvSpPr>
           <p:nvPr>
-            <p:ph idx="100" type="title" hasCustomPrompt="1"/>
+            <p:ph type="title" idx="100" hasCustomPrompt="1"/>
           </p:nvPr>
         </p:nvSpPr>
         <p:spPr>
@@ -1243,7 +995,7 @@
         <p:txBody>
           <a:bodyPr wrap="square" rtlCol="0"/>
           <a:lstStyle>
-            <a:lvl1pPr indent="0" marL="0">
+            <a:lvl1pPr marL="0" indent="0">
               <a:buNone/>
               <a:defRPr lang="en-US" sz="4000" b="1" dirty="0">
                 <a:solidFill>
@@ -1253,7 +1005,7 @@
             </a:lvl1pPr>
           </a:lstStyle>
           <a:p>
-            <a:pPr indent="0" marL="0">
+            <a:pPr marL="0" indent="0">
               <a:buNone/>
             </a:pPr>
             <a:endParaRPr lang="en-US" sz="4000" dirty="0"/>
@@ -1276,6 +1028,7 @@
         <a:solidFill>
           <a:srgbClr val="FFFFFF"/>
         </a:solidFill>
+        <a:effectLst/>
       </p:bgPr>
     </p:bg>
     <p:spTree>
@@ -1295,9 +1048,11 @@
       <p:sp>
         <p:nvSpPr>
           <p:cNvPr id="2" name="Text 0"/>
-          <p:cNvSpPr/>
+          <p:cNvSpPr>
+            <a:spLocks noGrp="1"/>
+          </p:cNvSpPr>
           <p:nvPr>
-            <p:ph idx="100" type="title" hasCustomPrompt="1"/>
+            <p:ph type="title" idx="100" hasCustomPrompt="1"/>
           </p:nvPr>
         </p:nvSpPr>
         <p:spPr>
@@ -1314,7 +1069,7 @@
         <p:txBody>
           <a:bodyPr wrap="square" rtlCol="0"/>
           <a:lstStyle>
-            <a:lvl1pPr algn="l" indent="0" marL="0">
+            <a:lvl1pPr marL="0" indent="0" algn="l">
               <a:buNone/>
               <a:defRPr lang="en-US" sz="3400" b="1" dirty="0">
                 <a:solidFill>
@@ -1324,7 +1079,7 @@
             </a:lvl1pPr>
           </a:lstStyle>
           <a:p>
-            <a:pPr algn="l" indent="0" marL="0">
+            <a:pPr marL="0" indent="0" algn="l">
               <a:buNone/>
             </a:pPr>
             <a:endParaRPr lang="en-US" sz="3400" dirty="0"/>
@@ -1351,7 +1106,7 @@
           </a:prstGeom>
           <a:extLst>
             <a:ext uri="{C572A759-6A51-4108-AA02-DFA0A04FC94B}">
-              <ma14:wrappingTextBoxFlag xmlns:ma14="http://schemas.microsoft.com/office/mac/drawingml/2011/main" val="0"/>
+              <ma14:wrappingTextBoxFlag xmlns:ma14="http://schemas.microsoft.com/office/mac/drawingml/2011/main" xmlns="" val="0"/>
             </a:ext>
           </a:extLst>
         </p:spPr>
@@ -1369,8 +1124,8 @@
           <a:p>
             <a:pPr algn="l"/>
             <a:fld id="{F7021451-1387-4CA6-816F-3879F97B5CBC}" type="slidenum">
-              <a:rPr b="0" lang="en-US"/>
-              <a:t>1003</a:t>
+              <a:rPr lang="en-US" b="0"/>
+              <a:t>‹Nº›</a:t>
             </a:fld>
             <a:endParaRPr lang="en-US"/>
           </a:p>
@@ -1387,6 +1142,11 @@
 <file path=ppt/slideMasters/slideMaster1.xml><?xml version="1.0" encoding="utf-8"?>
 <p:sldMaster xmlns:a="http://schemas.openxmlformats.org/drawingml/2006/main" xmlns:r="http://schemas.openxmlformats.org/officeDocument/2006/relationships" xmlns:p="http://schemas.openxmlformats.org/presentationml/2006/main">
   <p:cSld>
+    <p:bg>
+      <p:bgRef idx="1001">
+        <a:schemeClr val="bg1"/>
+      </p:bgRef>
+    </p:bg>
     <p:spTree>
       <p:nvGrpSpPr>
         <p:cNvPr id="1" name=""/>
@@ -1421,7 +1181,7 @@
           </a:prstGeom>
           <a:extLst>
             <a:ext uri="{C572A759-6A51-4108-AA02-DFA0A04FC94B}">
-              <ma14:wrappingTextBoxFlag xmlns:ma14="http://schemas.microsoft.com/office/mac/drawingml/2011/main" val="0"/>
+              <ma14:wrappingTextBoxFlag xmlns:ma14="http://schemas.microsoft.com/office/mac/drawingml/2011/main" xmlns="" val="0"/>
             </a:ext>
           </a:extLst>
         </p:spPr>
@@ -1439,8 +1199,8 @@
           <a:p>
             <a:pPr algn="l"/>
             <a:fld id="{F7021451-1387-4CA6-816F-3879F97B5CBC}" type="slidenum">
-              <a:rPr b="0" lang="en-US"/>
-              <a:t>null</a:t>
+              <a:rPr lang="en-US" b="0"/>
+              <a:t>‹Nº›</a:t>
             </a:fld>
             <a:endParaRPr lang="en-US"/>
           </a:p>
@@ -1728,9 +1488,11 @@
       <p:sp>
         <p:nvSpPr>
           <p:cNvPr id="2" name="Text 0"/>
-          <p:cNvSpPr/>
+          <p:cNvSpPr>
+            <a:spLocks noGrp="1"/>
+          </p:cNvSpPr>
           <p:nvPr>
-            <p:ph idx="100" type="title" hasCustomPrompt="1"/>
+            <p:ph type="title" idx="100" hasCustomPrompt="1"/>
           </p:nvPr>
         </p:nvSpPr>
         <p:spPr>
@@ -1748,54 +1510,128 @@
           <a:bodyPr wrap="square" lIns="0" tIns="0" rIns="0" bIns="0" rtlCol="0" anchor="ctr"/>
           <a:lstStyle/>
           <a:p>
-            <a:pPr indent="0" marL="0">
-              <a:buNone/>
-            </a:pPr>
-            <a:r>
-              <a:rPr lang="en-US" sz="4000" b="1" dirty="0">
+            <a:r>
+              <a:rPr lang="es-419" dirty="0"/>
+              <a:t>Arquitectura Orientada a Servicios (SOA)</a:t>
+            </a:r>
+            <a:endParaRPr lang="en-US" sz="4000" dirty="0"/>
+          </a:p>
+        </p:txBody>
+      </p:sp>
+      <p:sp>
+        <p:nvSpPr>
+          <p:cNvPr id="5" name="CuadroTexto 4">
+            <a:extLst>
+              <a:ext uri="{FF2B5EF4-FFF2-40B4-BE49-F238E27FC236}">
+                <a16:creationId xmlns:a16="http://schemas.microsoft.com/office/drawing/2014/main" id="{BDFDCA49-15E5-9528-7942-58D1A631B8E2}"/>
+              </a:ext>
+            </a:extLst>
+          </p:cNvPr>
+          <p:cNvSpPr txBox="1"/>
+          <p:nvPr/>
+        </p:nvSpPr>
+        <p:spPr>
+          <a:xfrm>
+            <a:off x="607423" y="3448594"/>
+            <a:ext cx="4572000" cy="1292662"/>
+          </a:xfrm>
+          <a:prstGeom prst="rect">
+            <a:avLst/>
+          </a:prstGeom>
+          <a:noFill/>
+        </p:spPr>
+        <p:txBody>
+          <a:bodyPr wrap="square">
+            <a:spAutoFit/>
+          </a:bodyPr>
+          <a:lstStyle/>
+          <a:p>
+            <a:pPr indent="0" algn="l">
+              <a:spcBef>
+                <a:spcPts val="1800"/>
+              </a:spcBef>
+              <a:spcAft>
+                <a:spcPts val="1200"/>
+              </a:spcAft>
+              <a:buNone/>
+            </a:pPr>
+            <a:r>
+              <a:rPr lang="es-419" sz="1200" b="1" i="0" dirty="0">
+                <a:solidFill>
+                  <a:srgbClr val="1F2328"/>
+                </a:solidFill>
+                <a:effectLst/>
+                <a:latin typeface="Mona Sans VF"/>
+              </a:rPr>
+              <a:t> </a:t>
+            </a:r>
+            <a:r>
+              <a:rPr lang="es-419" sz="1200" b="1" i="0" dirty="0">
                 <a:solidFill>
                   <a:schemeClr val="bg1"/>
                 </a:solidFill>
-              </a:rPr>
-              <a:t>SOA: patrones Observer y Mediator</a:t>
-            </a:r>
-            <a:endParaRPr lang="en-US" sz="4000" dirty="0"/>
-          </a:p>
-        </p:txBody>
-      </p:sp>
-      <p:sp>
-        <p:nvSpPr>
-          <p:cNvPr id="3" name="Text 1"/>
-          <p:cNvSpPr txBox="1"/>
-          <p:nvPr/>
-        </p:nvSpPr>
-        <p:spPr>
-          <a:xfrm>
-            <a:off x="731520" y="3108960"/>
-            <a:ext cx="7315200" cy="457200"/>
-          </a:xfrm>
-          <a:prstGeom prst="rect">
-            <a:avLst/>
-          </a:prstGeom>
-          <a:noFill/>
-          <a:ln/>
-        </p:spPr>
-        <p:txBody>
-          <a:bodyPr wrap="square" lIns="0" tIns="0" rIns="0" bIns="0" rtlCol="0" anchor="t"/>
-          <a:lstStyle/>
-          <a:p>
-            <a:pPr indent="0" marL="0">
-              <a:buNone/>
-            </a:pPr>
-            <a:r>
-              <a:rPr lang="en-US" sz="1800" dirty="0">
-                <a:solidFill>
-                  <a:schemeClr val="bg2"/>
-                </a:solidFill>
-              </a:rPr>
-              <a:t>Exposición de POO  ·  Aprendiz SENA</a:t>
-            </a:r>
-            <a:endParaRPr lang="en-US" sz="1800" dirty="0"/>
+                <a:effectLst/>
+                <a:latin typeface="Mona Sans VF"/>
+              </a:rPr>
+              <a:t>Integrantes del Equipo</a:t>
+            </a:r>
+          </a:p>
+          <a:p>
+            <a:pPr marL="342900" lvl="0" indent="-342900" algn="l">
+              <a:spcAft>
+                <a:spcPts val="1200"/>
+              </a:spcAft>
+              <a:buFont typeface="Arial" panose="020B0604020202020204" pitchFamily="34" charset="0"/>
+              <a:buChar char="•"/>
+            </a:pPr>
+            <a:r>
+              <a:rPr lang="es-419" sz="1200" b="0" i="0" dirty="0">
+                <a:solidFill>
+                  <a:schemeClr val="bg1"/>
+                </a:solidFill>
+                <a:effectLst/>
+                <a:latin typeface="Mona Sans VF"/>
+              </a:rPr>
+              <a:t>David Villanueva Potosí</a:t>
+            </a:r>
+          </a:p>
+          <a:p>
+            <a:pPr marL="342900" lvl="0" indent="-342900" algn="l">
+              <a:spcAft>
+                <a:spcPts val="1200"/>
+              </a:spcAft>
+              <a:buFont typeface="Arial" panose="020B0604020202020204" pitchFamily="34" charset="0"/>
+              <a:buChar char="•"/>
+            </a:pPr>
+            <a:r>
+              <a:rPr lang="es-419" sz="1200" b="0" i="0" dirty="0">
+                <a:solidFill>
+                  <a:schemeClr val="bg1"/>
+                </a:solidFill>
+                <a:effectLst/>
+                <a:latin typeface="Mona Sans VF"/>
+              </a:rPr>
+              <a:t>Brandon Duván Guevara Rodríguez</a:t>
+            </a:r>
+          </a:p>
+          <a:p>
+            <a:pPr marL="342900" lvl="0" indent="-342900" algn="l">
+              <a:spcAft>
+                <a:spcPts val="1200"/>
+              </a:spcAft>
+              <a:buFont typeface="Arial" panose="020B0604020202020204" pitchFamily="34" charset="0"/>
+              <a:buChar char="•"/>
+            </a:pPr>
+            <a:r>
+              <a:rPr lang="es-419" sz="1200" b="0" i="0" dirty="0">
+                <a:solidFill>
+                  <a:schemeClr val="bg1"/>
+                </a:solidFill>
+                <a:effectLst/>
+                <a:latin typeface="Mona Sans VF"/>
+              </a:rPr>
+              <a:t>Erick Santiago Vasquez Reyes</a:t>
+            </a:r>
           </a:p>
         </p:txBody>
       </p:sp>
@@ -1827,9 +1663,11 @@
       <p:sp>
         <p:nvSpPr>
           <p:cNvPr id="2" name="Text 0"/>
-          <p:cNvSpPr/>
+          <p:cNvSpPr>
+            <a:spLocks noGrp="1"/>
+          </p:cNvSpPr>
           <p:nvPr>
-            <p:ph idx="100" type="title" hasCustomPrompt="1"/>
+            <p:ph type="title" idx="100" hasCustomPrompt="1"/>
           </p:nvPr>
         </p:nvSpPr>
         <p:spPr>
@@ -1847,7 +1685,7 @@
           <a:bodyPr wrap="square" lIns="0" tIns="0" rIns="0" bIns="0" rtlCol="0" anchor="ctr"/>
           <a:lstStyle/>
           <a:p>
-            <a:pPr algn="l" indent="0" marL="0">
+            <a:pPr marL="0" indent="0" algn="l">
               <a:buNone/>
             </a:pPr>
             <a:r>
@@ -1883,7 +1721,7 @@
           <a:bodyPr wrap="square" lIns="0" tIns="0" rIns="0" bIns="0" rtlCol="0" anchor="t"/>
           <a:lstStyle/>
           <a:p>
-            <a:pPr indent="0" marL="0">
+            <a:pPr marL="0" indent="0">
               <a:spcAft>
                 <a:spcPts val="1000"/>
               </a:spcAft>
@@ -1897,24 +1735,43 @@
               </a:rPr>
               <a:t>Qué es: </a:t>
             </a:r>
-            <a:pPr indent="0" marL="0">
+            <a:r>
+              <a:rPr lang="en-US" sz="1500" dirty="0">
+                <a:solidFill>
+                  <a:schemeClr val="tx1"/>
+                </a:solidFill>
+              </a:rPr>
+              <a:t>estilo de arquitectura que divide el software en servicios independientes. Cada uno hace una función de negocio y publica un contrato.</a:t>
+            </a:r>
+            <a:endParaRPr lang="en-US" sz="1500" dirty="0"/>
+          </a:p>
+          <a:p>
+            <a:pPr marL="0" indent="0">
               <a:spcAft>
                 <a:spcPts val="1000"/>
               </a:spcAft>
               <a:buNone/>
             </a:pPr>
             <a:r>
+              <a:rPr lang="en-US" sz="1500" b="1" dirty="0">
+                <a:solidFill>
+                  <a:schemeClr val="tx2"/>
+                </a:solidFill>
+              </a:rPr>
+              <a:t>Metáfora: </a:t>
+            </a:r>
+            <a:r>
               <a:rPr lang="en-US" sz="1500" dirty="0">
                 <a:solidFill>
                   <a:schemeClr val="tx1"/>
                 </a:solidFill>
               </a:rPr>
-              <a:t>estilo de arquitectura que divide el software en servicios independientes. Cada uno hace una función de negocio y publica un contrato.</a:t>
+              <a:t>un centro comercial; cada local hace una cosa y, si uno cierra, los demás siguen abiertos.</a:t>
             </a:r>
             <a:endParaRPr lang="en-US" sz="1500" dirty="0"/>
           </a:p>
           <a:p>
-            <a:pPr indent="0" marL="0">
+            <a:pPr marL="0" indent="0">
               <a:spcAft>
                 <a:spcPts val="1000"/>
               </a:spcAft>
@@ -1926,45 +1783,8 @@
                   <a:schemeClr val="tx2"/>
                 </a:solidFill>
               </a:rPr>
-              <a:t>Metáfora: </a:t>
-            </a:r>
-            <a:pPr indent="0" marL="0">
-              <a:spcAft>
-                <a:spcPts val="1000"/>
-              </a:spcAft>
-              <a:buNone/>
-            </a:pPr>
-            <a:r>
-              <a:rPr lang="en-US" sz="1500" dirty="0">
-                <a:solidFill>
-                  <a:schemeClr val="tx1"/>
-                </a:solidFill>
-              </a:rPr>
-              <a:t>un centro comercial; cada local hace una cosa y, si uno cierra, los demás siguen abiertos.</a:t>
-            </a:r>
-            <a:endParaRPr lang="en-US" sz="1500" dirty="0"/>
-          </a:p>
-          <a:p>
-            <a:pPr indent="0" marL="0">
-              <a:spcAft>
-                <a:spcPts val="1000"/>
-              </a:spcAft>
-              <a:buNone/>
-            </a:pPr>
-            <a:r>
-              <a:rPr lang="en-US" sz="1500" b="1" dirty="0">
-                <a:solidFill>
-                  <a:schemeClr val="tx2"/>
-                </a:solidFill>
-              </a:rPr>
               <a:t>Sirve para: </a:t>
             </a:r>
-            <a:pPr indent="0" marL="0">
-              <a:spcAft>
-                <a:spcPts val="1000"/>
-              </a:spcAft>
-              <a:buNone/>
-            </a:pPr>
             <a:r>
               <a:rPr lang="en-US" sz="1500" dirty="0">
                 <a:solidFill>
@@ -1999,6 +1819,13 @@
             <a:prstDash val="solid"/>
           </a:ln>
         </p:spPr>
+        <p:txBody>
+          <a:bodyPr/>
+          <a:lstStyle/>
+          <a:p>
+            <a:endParaRPr lang="es-419"/>
+          </a:p>
+        </p:txBody>
       </p:sp>
       <p:sp>
         <p:nvSpPr>
@@ -2021,7 +1848,7 @@
           <a:bodyPr wrap="square" lIns="0" tIns="0" rIns="0" bIns="0" rtlCol="0" anchor="t"/>
           <a:lstStyle/>
           <a:p>
-            <a:pPr indent="0" marL="0">
+            <a:pPr marL="0" indent="0">
               <a:buNone/>
             </a:pPr>
             <a:r>
@@ -2057,7 +1884,7 @@
           <a:bodyPr wrap="square" lIns="0" tIns="0" rIns="0" bIns="0" rtlCol="0" anchor="t"/>
           <a:lstStyle/>
           <a:p>
-            <a:pPr indent="0" marL="0">
+            <a:pPr marL="0" indent="0">
               <a:spcAft>
                 <a:spcPts val="600"/>
               </a:spcAft>
@@ -2071,24 +1898,43 @@
               </a:rPr>
               <a:t>Contrato estándar: </a:t>
             </a:r>
-            <a:pPr indent="0" marL="0">
+            <a:r>
+              <a:rPr lang="en-US" sz="1300" dirty="0">
+                <a:solidFill>
+                  <a:schemeClr val="tx1"/>
+                </a:solidFill>
+              </a:rPr>
+              <a:t>describe qué ofrece.</a:t>
+            </a:r>
+            <a:endParaRPr lang="en-US" sz="1300" dirty="0"/>
+          </a:p>
+          <a:p>
+            <a:pPr marL="0" indent="0">
               <a:spcAft>
                 <a:spcPts val="600"/>
               </a:spcAft>
               <a:buNone/>
             </a:pPr>
             <a:r>
+              <a:rPr lang="en-US" sz="1300" b="1" dirty="0">
+                <a:solidFill>
+                  <a:schemeClr val="tx2"/>
+                </a:solidFill>
+              </a:rPr>
+              <a:t>Bajo acoplamiento: </a:t>
+            </a:r>
+            <a:r>
               <a:rPr lang="en-US" sz="1300" dirty="0">
                 <a:solidFill>
                   <a:schemeClr val="tx1"/>
                 </a:solidFill>
               </a:rPr>
-              <a:t>describe qué ofrece.</a:t>
+              <a:t>depende del contrato, no del código.</a:t>
             </a:r>
             <a:endParaRPr lang="en-US" sz="1300" dirty="0"/>
           </a:p>
           <a:p>
-            <a:pPr indent="0" marL="0">
+            <a:pPr marL="0" indent="0">
               <a:spcAft>
                 <a:spcPts val="600"/>
               </a:spcAft>
@@ -2100,26 +1946,45 @@
                   <a:schemeClr val="tx2"/>
                 </a:solidFill>
               </a:rPr>
-              <a:t>Bajo acoplamiento: </a:t>
-            </a:r>
-            <a:pPr indent="0" marL="0">
+              <a:t>Reutilización: </a:t>
+            </a:r>
+            <a:r>
+              <a:rPr lang="en-US" sz="1300" dirty="0">
+                <a:solidFill>
+                  <a:schemeClr val="tx1"/>
+                </a:solidFill>
+              </a:rPr>
+              <a:t>varias apps usan el mismo servicio.</a:t>
+            </a:r>
+            <a:endParaRPr lang="en-US" sz="1300" dirty="0"/>
+          </a:p>
+          <a:p>
+            <a:pPr marL="0" indent="0">
               <a:spcAft>
                 <a:spcPts val="600"/>
               </a:spcAft>
               <a:buNone/>
             </a:pPr>
             <a:r>
+              <a:rPr lang="en-US" sz="1300" b="1" dirty="0">
+                <a:solidFill>
+                  <a:schemeClr val="tx2"/>
+                </a:solidFill>
+              </a:rPr>
+              <a:t>Autonomía: </a:t>
+            </a:r>
+            <a:r>
               <a:rPr lang="en-US" sz="1300" dirty="0">
                 <a:solidFill>
                   <a:schemeClr val="tx1"/>
                 </a:solidFill>
               </a:rPr>
-              <a:t>depende del contrato, no del código.</a:t>
+              <a:t>cada servicio controla su lógica y datos.</a:t>
             </a:r>
             <a:endParaRPr lang="en-US" sz="1300" dirty="0"/>
           </a:p>
           <a:p>
-            <a:pPr indent="0" marL="0">
+            <a:pPr marL="0" indent="0">
               <a:spcAft>
                 <a:spcPts val="600"/>
               </a:spcAft>
@@ -2131,107 +1996,33 @@
                   <a:schemeClr val="tx2"/>
                 </a:solidFill>
               </a:rPr>
-              <a:t>Reutilización: </a:t>
-            </a:r>
-            <a:pPr indent="0" marL="0">
+              <a:t>Abstracción: </a:t>
+            </a:r>
+            <a:r>
+              <a:rPr lang="en-US" sz="1300" dirty="0">
+                <a:solidFill>
+                  <a:schemeClr val="tx1"/>
+                </a:solidFill>
+              </a:rPr>
+              <a:t>el consumidor no ve el interior.</a:t>
+            </a:r>
+            <a:endParaRPr lang="en-US" sz="1300" dirty="0"/>
+          </a:p>
+          <a:p>
+            <a:pPr marL="0" indent="0">
               <a:spcAft>
                 <a:spcPts val="600"/>
               </a:spcAft>
               <a:buNone/>
             </a:pPr>
             <a:r>
-              <a:rPr lang="en-US" sz="1300" dirty="0">
-                <a:solidFill>
-                  <a:schemeClr val="tx1"/>
-                </a:solidFill>
-              </a:rPr>
-              <a:t>varias apps usan el mismo servicio.</a:t>
-            </a:r>
-            <a:endParaRPr lang="en-US" sz="1300" dirty="0"/>
-          </a:p>
-          <a:p>
-            <a:pPr indent="0" marL="0">
-              <a:spcAft>
-                <a:spcPts val="600"/>
-              </a:spcAft>
-              <a:buNone/>
-            </a:pPr>
-            <a:r>
               <a:rPr lang="en-US" sz="1300" b="1" dirty="0">
                 <a:solidFill>
                   <a:schemeClr val="tx2"/>
                 </a:solidFill>
               </a:rPr>
-              <a:t>Autonomía: </a:t>
-            </a:r>
-            <a:pPr indent="0" marL="0">
-              <a:spcAft>
-                <a:spcPts val="600"/>
-              </a:spcAft>
-              <a:buNone/>
-            </a:pPr>
-            <a:r>
-              <a:rPr lang="en-US" sz="1300" dirty="0">
-                <a:solidFill>
-                  <a:schemeClr val="tx1"/>
-                </a:solidFill>
-              </a:rPr>
-              <a:t>cada servicio controla su lógica y datos.</a:t>
-            </a:r>
-            <a:endParaRPr lang="en-US" sz="1300" dirty="0"/>
-          </a:p>
-          <a:p>
-            <a:pPr indent="0" marL="0">
-              <a:spcAft>
-                <a:spcPts val="600"/>
-              </a:spcAft>
-              <a:buNone/>
-            </a:pPr>
-            <a:r>
-              <a:rPr lang="en-US" sz="1300" b="1" dirty="0">
-                <a:solidFill>
-                  <a:schemeClr val="tx2"/>
-                </a:solidFill>
-              </a:rPr>
-              <a:t>Abstracción: </a:t>
-            </a:r>
-            <a:pPr indent="0" marL="0">
-              <a:spcAft>
-                <a:spcPts val="600"/>
-              </a:spcAft>
-              <a:buNone/>
-            </a:pPr>
-            <a:r>
-              <a:rPr lang="en-US" sz="1300" dirty="0">
-                <a:solidFill>
-                  <a:schemeClr val="tx1"/>
-                </a:solidFill>
-              </a:rPr>
-              <a:t>el consumidor no ve el interior.</a:t>
-            </a:r>
-            <a:endParaRPr lang="en-US" sz="1300" dirty="0"/>
-          </a:p>
-          <a:p>
-            <a:pPr indent="0" marL="0">
-              <a:spcAft>
-                <a:spcPts val="600"/>
-              </a:spcAft>
-              <a:buNone/>
-            </a:pPr>
-            <a:r>
-              <a:rPr lang="en-US" sz="1300" b="1" dirty="0">
-                <a:solidFill>
-                  <a:schemeClr val="tx2"/>
-                </a:solidFill>
-              </a:rPr>
               <a:t>Composición: </a:t>
             </a:r>
-            <a:pPr indent="0" marL="0">
-              <a:spcAft>
-                <a:spcPts val="600"/>
-              </a:spcAft>
-              <a:buNone/>
-            </a:pPr>
             <a:r>
               <a:rPr lang="en-US" sz="1300" dirty="0">
                 <a:solidFill>
@@ -2264,7 +2055,7 @@
           </a:prstGeom>
           <a:extLst>
             <a:ext uri="{C572A759-6A51-4108-AA02-DFA0A04FC94B}">
-              <ma14:wrappingTextBoxFlag xmlns:ma14="http://schemas.microsoft.com/office/mac/drawingml/2011/main" val="0"/>
+              <ma14:wrappingTextBoxFlag xmlns:ma14="http://schemas.microsoft.com/office/mac/drawingml/2011/main" xmlns="" val="0"/>
             </a:ext>
           </a:extLst>
         </p:spPr>
@@ -2282,7 +2073,7 @@
           <a:p>
             <a:pPr algn="l"/>
             <a:fld id="{F7021451-1387-4CA6-816F-3879F97B5CBC}" type="slidenum">
-              <a:rPr b="0" lang="en-US"/>
+              <a:rPr lang="en-US" b="0"/>
               <a:t>2</a:t>
             </a:fld>
             <a:endParaRPr lang="en-US"/>
@@ -2317,9 +2108,11 @@
       <p:sp>
         <p:nvSpPr>
           <p:cNvPr id="2" name="Text 0"/>
-          <p:cNvSpPr/>
+          <p:cNvSpPr>
+            <a:spLocks noGrp="1"/>
+          </p:cNvSpPr>
           <p:nvPr>
-            <p:ph idx="100" type="title" hasCustomPrompt="1"/>
+            <p:ph type="title" idx="100" hasCustomPrompt="1"/>
           </p:nvPr>
         </p:nvSpPr>
         <p:spPr>
@@ -2337,7 +2130,7 @@
           <a:bodyPr wrap="square" lIns="0" tIns="0" rIns="0" bIns="0" rtlCol="0" anchor="ctr"/>
           <a:lstStyle/>
           <a:p>
-            <a:pPr algn="l" indent="0" marL="0">
+            <a:pPr marL="0" indent="0" algn="l">
               <a:buNone/>
             </a:pPr>
             <a:r>
@@ -2373,7 +2166,7 @@
           <a:bodyPr wrap="square" lIns="0" tIns="0" rIns="0" bIns="0" rtlCol="0" anchor="t"/>
           <a:lstStyle/>
           <a:p>
-            <a:pPr indent="0" marL="0">
+            <a:pPr marL="0" indent="0">
               <a:buNone/>
             </a:pPr>
             <a:r>
@@ -2409,7 +2202,7 @@
           <a:bodyPr wrap="square" lIns="0" tIns="0" rIns="0" bIns="0" rtlCol="0" anchor="t"/>
           <a:lstStyle/>
           <a:p>
-            <a:pPr indent="0" marL="0">
+            <a:pPr marL="0" indent="0">
               <a:spcAft>
                 <a:spcPts val="800"/>
               </a:spcAft>
@@ -2423,24 +2216,43 @@
               </a:rPr>
               <a:t>Proveedor: </a:t>
             </a:r>
-            <a:pPr indent="0" marL="0">
+            <a:r>
+              <a:rPr lang="en-US" sz="1400" dirty="0">
+                <a:solidFill>
+                  <a:schemeClr val="tx1"/>
+                </a:solidFill>
+              </a:rPr>
+              <a:t>implementa y publica el servicio.</a:t>
+            </a:r>
+            <a:endParaRPr lang="en-US" sz="1400" dirty="0"/>
+          </a:p>
+          <a:p>
+            <a:pPr marL="0" indent="0">
               <a:spcAft>
                 <a:spcPts val="800"/>
               </a:spcAft>
               <a:buNone/>
             </a:pPr>
             <a:r>
+              <a:rPr lang="en-US" sz="1400" b="1" dirty="0">
+                <a:solidFill>
+                  <a:schemeClr val="tx2"/>
+                </a:solidFill>
+              </a:rPr>
+              <a:t>Consumidor: </a:t>
+            </a:r>
+            <a:r>
               <a:rPr lang="en-US" sz="1400" dirty="0">
                 <a:solidFill>
                   <a:schemeClr val="tx1"/>
                 </a:solidFill>
               </a:rPr>
-              <a:t>implementa y publica el servicio.</a:t>
+              <a:t>lo busca y lo usa (app web o móvil).</a:t>
             </a:r>
             <a:endParaRPr lang="en-US" sz="1400" dirty="0"/>
           </a:p>
           <a:p>
-            <a:pPr indent="0" marL="0">
+            <a:pPr marL="0" indent="0">
               <a:spcAft>
                 <a:spcPts val="800"/>
               </a:spcAft>
@@ -2452,76 +2264,33 @@
                   <a:schemeClr val="tx2"/>
                 </a:solidFill>
               </a:rPr>
-              <a:t>Consumidor: </a:t>
-            </a:r>
-            <a:pPr indent="0" marL="0">
+              <a:t>Registro: </a:t>
+            </a:r>
+            <a:r>
+              <a:rPr lang="en-US" sz="1400" dirty="0">
+                <a:solidFill>
+                  <a:schemeClr val="tx1"/>
+                </a:solidFill>
+              </a:rPr>
+              <a:t>catálogo donde se publican los contratos.</a:t>
+            </a:r>
+            <a:endParaRPr lang="en-US" sz="1400" dirty="0"/>
+          </a:p>
+          <a:p>
+            <a:pPr marL="0" indent="0">
               <a:spcAft>
                 <a:spcPts val="800"/>
               </a:spcAft>
               <a:buNone/>
             </a:pPr>
             <a:r>
-              <a:rPr lang="en-US" sz="1400" dirty="0">
-                <a:solidFill>
-                  <a:schemeClr val="tx1"/>
-                </a:solidFill>
-              </a:rPr>
-              <a:t>lo busca y lo usa (app web o móvil).</a:t>
-            </a:r>
-            <a:endParaRPr lang="en-US" sz="1400" dirty="0"/>
-          </a:p>
-          <a:p>
-            <a:pPr indent="0" marL="0">
-              <a:spcAft>
-                <a:spcPts val="800"/>
-              </a:spcAft>
-              <a:buNone/>
-            </a:pPr>
-            <a:r>
               <a:rPr lang="en-US" sz="1400" b="1" dirty="0">
                 <a:solidFill>
                   <a:schemeClr val="tx2"/>
                 </a:solidFill>
               </a:rPr>
-              <a:t>Registro: </a:t>
-            </a:r>
-            <a:pPr indent="0" marL="0">
-              <a:spcAft>
-                <a:spcPts val="800"/>
-              </a:spcAft>
-              <a:buNone/>
-            </a:pPr>
-            <a:r>
-              <a:rPr lang="en-US" sz="1400" dirty="0">
-                <a:solidFill>
-                  <a:schemeClr val="tx1"/>
-                </a:solidFill>
-              </a:rPr>
-              <a:t>catálogo donde se publican los contratos.</a:t>
-            </a:r>
-            <a:endParaRPr lang="en-US" sz="1400" dirty="0"/>
-          </a:p>
-          <a:p>
-            <a:pPr indent="0" marL="0">
-              <a:spcAft>
-                <a:spcPts val="800"/>
-              </a:spcAft>
-              <a:buNone/>
-            </a:pPr>
-            <a:r>
-              <a:rPr lang="en-US" sz="1400" b="1" dirty="0">
-                <a:solidFill>
-                  <a:schemeClr val="tx2"/>
-                </a:solidFill>
-              </a:rPr>
               <a:t>Capas: </a:t>
             </a:r>
-            <a:pPr indent="0" marL="0">
-              <a:spcAft>
-                <a:spcPts val="800"/>
-              </a:spcAft>
-              <a:buNone/>
-            </a:pPr>
             <a:r>
               <a:rPr lang="en-US" sz="1400" dirty="0">
                 <a:solidFill>
@@ -2556,6 +2325,13 @@
             <a:prstDash val="solid"/>
           </a:ln>
         </p:spPr>
+        <p:txBody>
+          <a:bodyPr/>
+          <a:lstStyle/>
+          <a:p>
+            <a:endParaRPr lang="es-419"/>
+          </a:p>
+        </p:txBody>
       </p:sp>
       <p:sp>
         <p:nvSpPr>
@@ -2578,7 +2354,7 @@
           <a:bodyPr wrap="square" lIns="0" tIns="0" rIns="0" bIns="0" rtlCol="0" anchor="t"/>
           <a:lstStyle/>
           <a:p>
-            <a:pPr indent="0" marL="0">
+            <a:pPr marL="0" indent="0">
               <a:buNone/>
             </a:pPr>
             <a:r>
@@ -2620,7 +2396,7 @@
               </a:spcAft>
               <a:buSzPct val="100000"/>
               <a:buFont typeface="+mj-lt"/>
-              <a:buAutoNum type="arabicPeriod" startAt="1"/>
+              <a:buAutoNum type="arabicPeriod"/>
             </a:pPr>
             <a:r>
               <a:rPr lang="en-US" sz="1400" dirty="0">
@@ -2639,7 +2415,7 @@
               </a:spcAft>
               <a:buSzPct val="100000"/>
               <a:buFont typeface="+mj-lt"/>
-              <a:buAutoNum type="arabicPeriod" startAt="1"/>
+              <a:buAutoNum type="arabicPeriod"/>
             </a:pPr>
             <a:r>
               <a:rPr lang="en-US" sz="1400" dirty="0">
@@ -2658,7 +2434,7 @@
               </a:spcAft>
               <a:buSzPct val="100000"/>
               <a:buFont typeface="+mj-lt"/>
-              <a:buAutoNum type="arabicPeriod" startAt="1"/>
+              <a:buAutoNum type="arabicPeriod"/>
             </a:pPr>
             <a:r>
               <a:rPr lang="en-US" sz="1400" dirty="0">
@@ -2677,7 +2453,7 @@
               </a:spcAft>
               <a:buSzPct val="100000"/>
               <a:buFont typeface="+mj-lt"/>
-              <a:buAutoNum type="arabicPeriod" startAt="1"/>
+              <a:buAutoNum type="arabicPeriod"/>
             </a:pPr>
             <a:r>
               <a:rPr lang="en-US" sz="1400" dirty="0">
@@ -2712,7 +2488,7 @@
           <a:bodyPr wrap="square" lIns="0" tIns="0" rIns="0" bIns="0" rtlCol="0" anchor="t"/>
           <a:lstStyle/>
           <a:p>
-            <a:pPr indent="0" marL="0">
+            <a:pPr marL="0" indent="0">
               <a:buNone/>
             </a:pPr>
             <a:r>
@@ -2723,9 +2499,6 @@
               </a:rPr>
               <a:t>Además: </a:t>
             </a:r>
-            <a:pPr indent="0" marL="0">
-              <a:buNone/>
-            </a:pPr>
             <a:r>
               <a:rPr lang="en-US" sz="1400" dirty="0">
                 <a:solidFill>
@@ -2758,7 +2531,7 @@
           </a:prstGeom>
           <a:extLst>
             <a:ext uri="{C572A759-6A51-4108-AA02-DFA0A04FC94B}">
-              <ma14:wrappingTextBoxFlag xmlns:ma14="http://schemas.microsoft.com/office/mac/drawingml/2011/main" val="0"/>
+              <ma14:wrappingTextBoxFlag xmlns:ma14="http://schemas.microsoft.com/office/mac/drawingml/2011/main" xmlns="" val="0"/>
             </a:ext>
           </a:extLst>
         </p:spPr>
@@ -2776,7 +2549,7 @@
           <a:p>
             <a:pPr algn="l"/>
             <a:fld id="{F7021451-1387-4CA6-816F-3879F97B5CBC}" type="slidenum">
-              <a:rPr b="0" lang="en-US"/>
+              <a:rPr lang="en-US" b="0"/>
               <a:t>3</a:t>
             </a:fld>
             <a:endParaRPr lang="en-US"/>
@@ -2811,9 +2584,11 @@
       <p:sp>
         <p:nvSpPr>
           <p:cNvPr id="2" name="Text 0"/>
-          <p:cNvSpPr/>
+          <p:cNvSpPr>
+            <a:spLocks noGrp="1"/>
+          </p:cNvSpPr>
           <p:nvPr>
-            <p:ph idx="100" type="title" hasCustomPrompt="1"/>
+            <p:ph type="title" idx="100" hasCustomPrompt="1"/>
           </p:nvPr>
         </p:nvSpPr>
         <p:spPr>
@@ -2831,7 +2606,7 @@
           <a:bodyPr wrap="square" lIns="0" tIns="0" rIns="0" bIns="0" rtlCol="0" anchor="ctr"/>
           <a:lstStyle/>
           <a:p>
-            <a:pPr algn="l" indent="0" marL="0">
+            <a:pPr marL="0" indent="0" algn="l">
               <a:buNone/>
             </a:pPr>
             <a:r>
@@ -2870,6 +2645,13 @@
             <a:prstDash val="solid"/>
           </a:ln>
         </p:spPr>
+        <p:txBody>
+          <a:bodyPr/>
+          <a:lstStyle/>
+          <a:p>
+            <a:endParaRPr lang="es-419"/>
+          </a:p>
+        </p:txBody>
       </p:sp>
       <p:sp>
         <p:nvSpPr>
@@ -2892,7 +2674,7 @@
           <a:bodyPr wrap="square" lIns="0" tIns="0" rIns="0" bIns="0" rtlCol="0" anchor="ctr"/>
           <a:lstStyle/>
           <a:p>
-            <a:pPr algn="ctr" indent="0" marL="0">
+            <a:pPr marL="0" indent="0" algn="ctr">
               <a:buNone/>
             </a:pPr>
             <a:r>
@@ -2931,6 +2713,13 @@
             <a:prstDash val="solid"/>
           </a:ln>
         </p:spPr>
+        <p:txBody>
+          <a:bodyPr/>
+          <a:lstStyle/>
+          <a:p>
+            <a:endParaRPr lang="es-419"/>
+          </a:p>
+        </p:txBody>
       </p:sp>
       <p:sp>
         <p:nvSpPr>
@@ -2953,7 +2742,7 @@
           <a:bodyPr wrap="square" lIns="0" tIns="0" rIns="0" bIns="0" rtlCol="0" anchor="ctr"/>
           <a:lstStyle/>
           <a:p>
-            <a:pPr algn="ctr" indent="0" marL="0">
+            <a:pPr marL="0" indent="0" algn="ctr">
               <a:buNone/>
             </a:pPr>
             <a:r>
@@ -2992,6 +2781,13 @@
             <a:prstDash val="solid"/>
           </a:ln>
         </p:spPr>
+        <p:txBody>
+          <a:bodyPr/>
+          <a:lstStyle/>
+          <a:p>
+            <a:endParaRPr lang="es-419"/>
+          </a:p>
+        </p:txBody>
       </p:sp>
       <p:sp>
         <p:nvSpPr>
@@ -3014,7 +2810,7 @@
           <a:bodyPr wrap="square" lIns="0" tIns="0" rIns="0" bIns="0" rtlCol="0" anchor="ctr"/>
           <a:lstStyle/>
           <a:p>
-            <a:pPr algn="ctr" indent="0" marL="0">
+            <a:pPr marL="0" indent="0" algn="ctr">
               <a:buNone/>
             </a:pPr>
             <a:r>
@@ -3052,6 +2848,13 @@
             <a:tailEnd type="triangle"/>
           </a:ln>
         </p:spPr>
+        <p:txBody>
+          <a:bodyPr/>
+          <a:lstStyle/>
+          <a:p>
+            <a:endParaRPr lang="es-419"/>
+          </a:p>
+        </p:txBody>
       </p:sp>
       <p:sp>
         <p:nvSpPr>
@@ -3077,6 +2880,13 @@
             <a:tailEnd type="none"/>
           </a:ln>
         </p:spPr>
+        <p:txBody>
+          <a:bodyPr/>
+          <a:lstStyle/>
+          <a:p>
+            <a:endParaRPr lang="es-419"/>
+          </a:p>
+        </p:txBody>
       </p:sp>
       <p:sp>
         <p:nvSpPr>
@@ -3101,6 +2911,13 @@
             <a:tailEnd type="triangle"/>
           </a:ln>
         </p:spPr>
+        <p:txBody>
+          <a:bodyPr/>
+          <a:lstStyle/>
+          <a:p>
+            <a:endParaRPr lang="es-419"/>
+          </a:p>
+        </p:txBody>
       </p:sp>
       <p:sp>
         <p:nvSpPr>
@@ -3126,6 +2943,13 @@
             <a:tailEnd type="none"/>
           </a:ln>
         </p:spPr>
+        <p:txBody>
+          <a:bodyPr/>
+          <a:lstStyle/>
+          <a:p>
+            <a:endParaRPr lang="es-419"/>
+          </a:p>
+        </p:txBody>
       </p:sp>
       <p:sp>
         <p:nvSpPr>
@@ -3148,7 +2972,7 @@
           <a:bodyPr wrap="square" lIns="0" tIns="0" rIns="0" bIns="0" rtlCol="0" anchor="t"/>
           <a:lstStyle/>
           <a:p>
-            <a:pPr algn="r" indent="0" marL="0">
+            <a:pPr marL="0" indent="0" algn="r">
               <a:buNone/>
             </a:pPr>
             <a:r>
@@ -3184,7 +3008,7 @@
           <a:bodyPr wrap="square" lIns="0" tIns="0" rIns="0" bIns="0" rtlCol="0" anchor="t"/>
           <a:lstStyle/>
           <a:p>
-            <a:pPr indent="0" marL="0">
+            <a:pPr marL="0" indent="0">
               <a:buNone/>
             </a:pPr>
             <a:r>
@@ -3220,7 +3044,7 @@
           <a:bodyPr wrap="square" lIns="0" tIns="0" rIns="0" bIns="0" rtlCol="0" anchor="t"/>
           <a:lstStyle/>
           <a:p>
-            <a:pPr algn="ctr" indent="0" marL="0">
+            <a:pPr marL="0" indent="0" algn="ctr">
               <a:buNone/>
             </a:pPr>
             <a:r>
@@ -3256,7 +3080,7 @@
           <a:bodyPr wrap="square" lIns="0" tIns="0" rIns="0" bIns="0" rtlCol="0" anchor="t"/>
           <a:lstStyle/>
           <a:p>
-            <a:pPr algn="ctr" indent="0" marL="0">
+            <a:pPr marL="0" indent="0" algn="ctr">
               <a:buNone/>
             </a:pPr>
             <a:r>
@@ -3293,6 +3117,13 @@
             <a:prstDash val="solid"/>
           </a:ln>
         </p:spPr>
+        <p:txBody>
+          <a:bodyPr/>
+          <a:lstStyle/>
+          <a:p>
+            <a:endParaRPr lang="es-419"/>
+          </a:p>
+        </p:txBody>
       </p:sp>
       <p:sp>
         <p:nvSpPr>
@@ -3315,7 +3146,7 @@
           <a:bodyPr wrap="square" lIns="0" tIns="0" rIns="0" bIns="0" rtlCol="0" anchor="t"/>
           <a:lstStyle/>
           <a:p>
-            <a:pPr indent="0" marL="0">
+            <a:pPr marL="0" indent="0">
               <a:spcAft>
                 <a:spcPts val="800"/>
               </a:spcAft>
@@ -3329,24 +3160,43 @@
               </a:rPr>
               <a:t>1 </a:t>
             </a:r>
-            <a:pPr indent="0" marL="0">
+            <a:r>
+              <a:rPr lang="en-US" sz="1400" dirty="0">
+                <a:solidFill>
+                  <a:schemeClr val="tx1"/>
+                </a:solidFill>
+              </a:rPr>
+              <a:t>El proveedor publica su contrato en el registro.</a:t>
+            </a:r>
+            <a:endParaRPr lang="en-US" sz="1400" dirty="0"/>
+          </a:p>
+          <a:p>
+            <a:pPr marL="0" indent="0">
               <a:spcAft>
                 <a:spcPts val="800"/>
               </a:spcAft>
               <a:buNone/>
             </a:pPr>
             <a:r>
+              <a:rPr lang="en-US" sz="1400" b="1" dirty="0">
+                <a:solidFill>
+                  <a:schemeClr val="tx2"/>
+                </a:solidFill>
+              </a:rPr>
+              <a:t>2 </a:t>
+            </a:r>
+            <a:r>
               <a:rPr lang="en-US" sz="1400" dirty="0">
                 <a:solidFill>
                   <a:schemeClr val="tx1"/>
                 </a:solidFill>
               </a:rPr>
-              <a:t>El proveedor publica su contrato en el registro.</a:t>
+              <a:t>El consumidor busca el servicio.</a:t>
             </a:r>
             <a:endParaRPr lang="en-US" sz="1400" dirty="0"/>
           </a:p>
           <a:p>
-            <a:pPr indent="0" marL="0">
+            <a:pPr marL="0" indent="0">
               <a:spcAft>
                 <a:spcPts val="800"/>
               </a:spcAft>
@@ -3358,76 +3208,33 @@
                   <a:schemeClr val="tx2"/>
                 </a:solidFill>
               </a:rPr>
-              <a:t>2 </a:t>
-            </a:r>
-            <a:pPr indent="0" marL="0">
+              <a:t>3 </a:t>
+            </a:r>
+            <a:r>
+              <a:rPr lang="en-US" sz="1400" dirty="0">
+                <a:solidFill>
+                  <a:schemeClr val="tx1"/>
+                </a:solidFill>
+              </a:rPr>
+              <a:t>Lo invoca con un mensaje.</a:t>
+            </a:r>
+            <a:endParaRPr lang="en-US" sz="1400" dirty="0"/>
+          </a:p>
+          <a:p>
+            <a:pPr marL="0" indent="0">
               <a:spcAft>
                 <a:spcPts val="800"/>
               </a:spcAft>
               <a:buNone/>
             </a:pPr>
             <a:r>
-              <a:rPr lang="en-US" sz="1400" dirty="0">
-                <a:solidFill>
-                  <a:schemeClr val="tx1"/>
-                </a:solidFill>
-              </a:rPr>
-              <a:t>El consumidor busca el servicio.</a:t>
-            </a:r>
-            <a:endParaRPr lang="en-US" sz="1400" dirty="0"/>
-          </a:p>
-          <a:p>
-            <a:pPr indent="0" marL="0">
-              <a:spcAft>
-                <a:spcPts val="800"/>
-              </a:spcAft>
-              <a:buNone/>
-            </a:pPr>
-            <a:r>
               <a:rPr lang="en-US" sz="1400" b="1" dirty="0">
                 <a:solidFill>
                   <a:schemeClr val="tx2"/>
                 </a:solidFill>
               </a:rPr>
-              <a:t>3 </a:t>
-            </a:r>
-            <a:pPr indent="0" marL="0">
-              <a:spcAft>
-                <a:spcPts val="800"/>
-              </a:spcAft>
-              <a:buNone/>
-            </a:pPr>
-            <a:r>
-              <a:rPr lang="en-US" sz="1400" dirty="0">
-                <a:solidFill>
-                  <a:schemeClr val="tx1"/>
-                </a:solidFill>
-              </a:rPr>
-              <a:t>Lo invoca con un mensaje.</a:t>
-            </a:r>
-            <a:endParaRPr lang="en-US" sz="1400" dirty="0"/>
-          </a:p>
-          <a:p>
-            <a:pPr indent="0" marL="0">
-              <a:spcAft>
-                <a:spcPts val="800"/>
-              </a:spcAft>
-              <a:buNone/>
-            </a:pPr>
-            <a:r>
-              <a:rPr lang="en-US" sz="1400" b="1" dirty="0">
-                <a:solidFill>
-                  <a:schemeClr val="tx2"/>
-                </a:solidFill>
-              </a:rPr>
               <a:t>4 </a:t>
             </a:r>
-            <a:pPr indent="0" marL="0">
-              <a:spcAft>
-                <a:spcPts val="800"/>
-              </a:spcAft>
-              <a:buNone/>
-            </a:pPr>
             <a:r>
               <a:rPr lang="en-US" sz="1400" dirty="0">
                 <a:solidFill>
@@ -3460,7 +3267,7 @@
           </a:prstGeom>
           <a:extLst>
             <a:ext uri="{C572A759-6A51-4108-AA02-DFA0A04FC94B}">
-              <ma14:wrappingTextBoxFlag xmlns:ma14="http://schemas.microsoft.com/office/mac/drawingml/2011/main" val="0"/>
+              <ma14:wrappingTextBoxFlag xmlns:ma14="http://schemas.microsoft.com/office/mac/drawingml/2011/main" xmlns="" val="0"/>
             </a:ext>
           </a:extLst>
         </p:spPr>
@@ -3478,7 +3285,7 @@
           <a:p>
             <a:pPr algn="l"/>
             <a:fld id="{F7021451-1387-4CA6-816F-3879F97B5CBC}" type="slidenum">
-              <a:rPr b="0" lang="en-US"/>
+              <a:rPr lang="en-US" b="0"/>
               <a:t>4</a:t>
             </a:fld>
             <a:endParaRPr lang="en-US"/>
@@ -3513,9 +3320,11 @@
       <p:sp>
         <p:nvSpPr>
           <p:cNvPr id="2" name="Text 0"/>
-          <p:cNvSpPr/>
+          <p:cNvSpPr>
+            <a:spLocks noGrp="1"/>
+          </p:cNvSpPr>
           <p:nvPr>
-            <p:ph idx="100" type="title" hasCustomPrompt="1"/>
+            <p:ph type="title" idx="100" hasCustomPrompt="1"/>
           </p:nvPr>
         </p:nvSpPr>
         <p:spPr>
@@ -3533,7 +3342,7 @@
           <a:bodyPr wrap="square" lIns="0" tIns="0" rIns="0" bIns="0" rtlCol="0" anchor="ctr"/>
           <a:lstStyle/>
           <a:p>
-            <a:pPr indent="0" marL="0">
+            <a:pPr marL="0" indent="0">
               <a:buNone/>
             </a:pPr>
             <a:r>
@@ -3545,42 +3354,6 @@
               <a:t>Patrones Observer y Mediator</a:t>
             </a:r>
             <a:endParaRPr lang="en-US" sz="4000" dirty="0"/>
-          </a:p>
-        </p:txBody>
-      </p:sp>
-      <p:sp>
-        <p:nvSpPr>
-          <p:cNvPr id="3" name="Text 1"/>
-          <p:cNvSpPr txBox="1"/>
-          <p:nvPr/>
-        </p:nvSpPr>
-        <p:spPr>
-          <a:xfrm>
-            <a:off x="731520" y="3108960"/>
-            <a:ext cx="7315200" cy="457200"/>
-          </a:xfrm>
-          <a:prstGeom prst="rect">
-            <a:avLst/>
-          </a:prstGeom>
-          <a:noFill/>
-          <a:ln/>
-        </p:spPr>
-        <p:txBody>
-          <a:bodyPr wrap="square" lIns="0" tIns="0" rIns="0" bIns="0" rtlCol="0" anchor="t"/>
-          <a:lstStyle/>
-          <a:p>
-            <a:pPr indent="0" marL="0">
-              <a:buNone/>
-            </a:pPr>
-            <a:r>
-              <a:rPr lang="en-US" sz="1800" dirty="0">
-                <a:solidFill>
-                  <a:schemeClr val="bg2"/>
-                </a:solidFill>
-              </a:rPr>
-              <a:t>Definición, características y diagramas</a:t>
-            </a:r>
-            <a:endParaRPr lang="en-US" sz="1800" dirty="0"/>
           </a:p>
         </p:txBody>
       </p:sp>
@@ -3612,9 +3385,11 @@
       <p:sp>
         <p:nvSpPr>
           <p:cNvPr id="2" name="Text 0"/>
-          <p:cNvSpPr/>
+          <p:cNvSpPr>
+            <a:spLocks noGrp="1"/>
+          </p:cNvSpPr>
           <p:nvPr>
-            <p:ph idx="100" type="title" hasCustomPrompt="1"/>
+            <p:ph type="title" idx="100" hasCustomPrompt="1"/>
           </p:nvPr>
         </p:nvSpPr>
         <p:spPr>
@@ -3632,7 +3407,7 @@
           <a:bodyPr wrap="square" lIns="0" tIns="0" rIns="0" bIns="0" rtlCol="0" anchor="ctr"/>
           <a:lstStyle/>
           <a:p>
-            <a:pPr algn="l" indent="0" marL="0">
+            <a:pPr marL="0" indent="0" algn="l">
               <a:buNone/>
             </a:pPr>
             <a:r>
@@ -3668,7 +3443,7 @@
           <a:bodyPr wrap="square" lIns="0" tIns="0" rIns="0" bIns="0" rtlCol="0" anchor="t"/>
           <a:lstStyle/>
           <a:p>
-            <a:pPr indent="0" marL="0">
+            <a:pPr marL="0" indent="0">
               <a:buNone/>
             </a:pPr>
             <a:r>
@@ -3704,7 +3479,7 @@
           <a:bodyPr wrap="square" lIns="0" tIns="0" rIns="0" bIns="0" rtlCol="0" anchor="t"/>
           <a:lstStyle/>
           <a:p>
-            <a:pPr indent="0" marL="0">
+            <a:pPr marL="0" indent="0">
               <a:buNone/>
             </a:pPr>
             <a:r>
@@ -3741,6 +3516,13 @@
             <a:prstDash val="solid"/>
           </a:ln>
         </p:spPr>
+        <p:txBody>
+          <a:bodyPr/>
+          <a:lstStyle/>
+          <a:p>
+            <a:endParaRPr lang="es-419"/>
+          </a:p>
+        </p:txBody>
       </p:sp>
       <p:sp>
         <p:nvSpPr>
@@ -3763,7 +3545,7 @@
           <a:bodyPr wrap="square" lIns="0" tIns="0" rIns="0" bIns="0" rtlCol="0" anchor="t"/>
           <a:lstStyle/>
           <a:p>
-            <a:pPr indent="0" marL="0">
+            <a:pPr marL="0" indent="0">
               <a:spcAft>
                 <a:spcPts val="800"/>
               </a:spcAft>
@@ -3777,24 +3559,43 @@
               </a:rPr>
               <a:t>Qué es: </a:t>
             </a:r>
-            <a:pPr indent="0" marL="0">
+            <a:r>
+              <a:rPr lang="en-US" sz="1400" dirty="0">
+                <a:solidFill>
+                  <a:schemeClr val="tx1"/>
+                </a:solidFill>
+              </a:rPr>
+              <a:t>relación uno a muchos; si el Subject cambia, avisa a todos sus Observers.</a:t>
+            </a:r>
+            <a:endParaRPr lang="en-US" sz="1400" dirty="0"/>
+          </a:p>
+          <a:p>
+            <a:pPr marL="0" indent="0">
               <a:spcAft>
                 <a:spcPts val="800"/>
               </a:spcAft>
               <a:buNone/>
             </a:pPr>
             <a:r>
+              <a:rPr lang="en-US" sz="1400" b="1" dirty="0">
+                <a:solidFill>
+                  <a:schemeClr val="tx2"/>
+                </a:solidFill>
+              </a:rPr>
+              <a:t>Metáfora: </a:t>
+            </a:r>
+            <a:r>
               <a:rPr lang="en-US" sz="1400" dirty="0">
                 <a:solidFill>
                   <a:schemeClr val="tx1"/>
                 </a:solidFill>
               </a:rPr>
-              <a:t>relación uno a muchos; si el Subject cambia, avisa a todos sus Observers.</a:t>
+              <a:t>un canal de YouTube y sus suscriptores.</a:t>
             </a:r>
             <a:endParaRPr lang="en-US" sz="1400" dirty="0"/>
           </a:p>
           <a:p>
-            <a:pPr indent="0" marL="0">
+            <a:pPr marL="0" indent="0">
               <a:spcAft>
                 <a:spcPts val="800"/>
               </a:spcAft>
@@ -3806,26 +3607,67 @@
                   <a:schemeClr val="tx2"/>
                 </a:solidFill>
               </a:rPr>
-              <a:t>Metáfora: </a:t>
-            </a:r>
-            <a:pPr indent="0" marL="0">
+              <a:t>Sirve para: </a:t>
+            </a:r>
+            <a:r>
+              <a:rPr lang="en-US" sz="1400" dirty="0">
+                <a:solidFill>
+                  <a:schemeClr val="tx1"/>
+                </a:solidFill>
+              </a:rPr>
+              <a:t>reaccionar a cambios sin que el emisor conozca a quién avisa.</a:t>
+            </a:r>
+            <a:endParaRPr lang="en-US" sz="1400" dirty="0"/>
+          </a:p>
+          <a:p>
+            <a:pPr marL="0" indent="0">
               <a:spcAft>
                 <a:spcPts val="800"/>
               </a:spcAft>
               <a:buNone/>
             </a:pPr>
             <a:r>
+              <a:rPr lang="en-US" sz="1400" b="1" dirty="0">
+                <a:solidFill>
+                  <a:schemeClr val="tx2"/>
+                </a:solidFill>
+              </a:rPr>
+              <a:t>En SOA: </a:t>
+            </a:r>
+            <a:r>
               <a:rPr lang="en-US" sz="1400" dirty="0">
                 <a:solidFill>
                   <a:schemeClr val="tx1"/>
                 </a:solidFill>
               </a:rPr>
-              <a:t>un canal de YouTube y sus suscriptores.</a:t>
+              <a:t>publish/subscribe con un broker (RabbitMQ, Kafka).</a:t>
             </a:r>
             <a:endParaRPr lang="en-US" sz="1400" dirty="0"/>
           </a:p>
-          <a:p>
-            <a:pPr indent="0" marL="0">
+        </p:txBody>
+      </p:sp>
+      <p:sp>
+        <p:nvSpPr>
+          <p:cNvPr id="7" name="Text 5"/>
+          <p:cNvSpPr txBox="1"/>
+          <p:nvPr/>
+        </p:nvSpPr>
+        <p:spPr>
+          <a:xfrm>
+            <a:off x="4846320" y="1508760"/>
+            <a:ext cx="3749040" cy="3108960"/>
+          </a:xfrm>
+          <a:prstGeom prst="rect">
+            <a:avLst/>
+          </a:prstGeom>
+          <a:noFill/>
+          <a:ln/>
+        </p:spPr>
+        <p:txBody>
+          <a:bodyPr wrap="square" lIns="0" tIns="0" rIns="0" bIns="0" rtlCol="0" anchor="t"/>
+          <a:lstStyle/>
+          <a:p>
+            <a:pPr marL="0" indent="0">
               <a:spcAft>
                 <a:spcPts val="800"/>
               </a:spcAft>
@@ -3837,26 +3679,45 @@
                   <a:schemeClr val="tx2"/>
                 </a:solidFill>
               </a:rPr>
-              <a:t>Sirve para: </a:t>
-            </a:r>
-            <a:pPr indent="0" marL="0">
+              <a:t>Qué es: </a:t>
+            </a:r>
+            <a:r>
+              <a:rPr lang="en-US" sz="1400" dirty="0">
+                <a:solidFill>
+                  <a:schemeClr val="tx1"/>
+                </a:solidFill>
+              </a:rPr>
+              <a:t>un intermediario que centraliza la comunicación entre componentes.</a:t>
+            </a:r>
+            <a:endParaRPr lang="en-US" sz="1400" dirty="0"/>
+          </a:p>
+          <a:p>
+            <a:pPr marL="0" indent="0">
               <a:spcAft>
                 <a:spcPts val="800"/>
               </a:spcAft>
               <a:buNone/>
             </a:pPr>
             <a:r>
+              <a:rPr lang="en-US" sz="1400" b="1" dirty="0">
+                <a:solidFill>
+                  <a:schemeClr val="tx2"/>
+                </a:solidFill>
+              </a:rPr>
+              <a:t>Metáfora: </a:t>
+            </a:r>
+            <a:r>
               <a:rPr lang="en-US" sz="1400" dirty="0">
                 <a:solidFill>
                   <a:schemeClr val="tx1"/>
                 </a:solidFill>
               </a:rPr>
-              <a:t>reaccionar a cambios sin que el emisor conozca a quién avisa.</a:t>
+              <a:t>la torre de control de un aeropuerto.</a:t>
             </a:r>
             <a:endParaRPr lang="en-US" sz="1400" dirty="0"/>
           </a:p>
           <a:p>
-            <a:pPr indent="0" marL="0">
+            <a:pPr marL="0" indent="0">
               <a:spcAft>
                 <a:spcPts val="800"/>
               </a:spcAft>
@@ -3868,160 +3729,33 @@
                   <a:schemeClr val="tx2"/>
                 </a:solidFill>
               </a:rPr>
-              <a:t>En SOA: </a:t>
-            </a:r>
-            <a:pPr indent="0" marL="0">
+              <a:t>Sirve para: </a:t>
+            </a:r>
+            <a:r>
+              <a:rPr lang="en-US" sz="1400" dirty="0">
+                <a:solidFill>
+                  <a:schemeClr val="tx1"/>
+                </a:solidFill>
+              </a:rPr>
+              <a:t>evitar una maraña de dependencias y coordinar en un solo lugar.</a:t>
+            </a:r>
+            <a:endParaRPr lang="en-US" sz="1400" dirty="0"/>
+          </a:p>
+          <a:p>
+            <a:pPr marL="0" indent="0">
               <a:spcAft>
                 <a:spcPts val="800"/>
               </a:spcAft>
               <a:buNone/>
             </a:pPr>
             <a:r>
-              <a:rPr lang="en-US" sz="1400" dirty="0">
-                <a:solidFill>
-                  <a:schemeClr val="tx1"/>
-                </a:solidFill>
-              </a:rPr>
-              <a:t>publish/subscribe con un broker (RabbitMQ, Kafka).</a:t>
-            </a:r>
-            <a:endParaRPr lang="en-US" sz="1400" dirty="0"/>
-          </a:p>
-        </p:txBody>
-      </p:sp>
-      <p:sp>
-        <p:nvSpPr>
-          <p:cNvPr id="7" name="Text 5"/>
-          <p:cNvSpPr txBox="1"/>
-          <p:nvPr/>
-        </p:nvSpPr>
-        <p:spPr>
-          <a:xfrm>
-            <a:off x="4846320" y="1508760"/>
-            <a:ext cx="3749040" cy="3108960"/>
-          </a:xfrm>
-          <a:prstGeom prst="rect">
-            <a:avLst/>
-          </a:prstGeom>
-          <a:noFill/>
-          <a:ln/>
-        </p:spPr>
-        <p:txBody>
-          <a:bodyPr wrap="square" lIns="0" tIns="0" rIns="0" bIns="0" rtlCol="0" anchor="t"/>
-          <a:lstStyle/>
-          <a:p>
-            <a:pPr indent="0" marL="0">
-              <a:spcAft>
-                <a:spcPts val="800"/>
-              </a:spcAft>
-              <a:buNone/>
-            </a:pPr>
-            <a:r>
               <a:rPr lang="en-US" sz="1400" b="1" dirty="0">
                 <a:solidFill>
                   <a:schemeClr val="tx2"/>
                 </a:solidFill>
               </a:rPr>
-              <a:t>Qué es: </a:t>
-            </a:r>
-            <a:pPr indent="0" marL="0">
-              <a:spcAft>
-                <a:spcPts val="800"/>
-              </a:spcAft>
-              <a:buNone/>
-            </a:pPr>
-            <a:r>
-              <a:rPr lang="en-US" sz="1400" dirty="0">
-                <a:solidFill>
-                  <a:schemeClr val="tx1"/>
-                </a:solidFill>
-              </a:rPr>
-              <a:t>un intermediario que centraliza la comunicación entre componentes.</a:t>
-            </a:r>
-            <a:endParaRPr lang="en-US" sz="1400" dirty="0"/>
-          </a:p>
-          <a:p>
-            <a:pPr indent="0" marL="0">
-              <a:spcAft>
-                <a:spcPts val="800"/>
-              </a:spcAft>
-              <a:buNone/>
-            </a:pPr>
-            <a:r>
-              <a:rPr lang="en-US" sz="1400" b="1" dirty="0">
-                <a:solidFill>
-                  <a:schemeClr val="tx2"/>
-                </a:solidFill>
-              </a:rPr>
-              <a:t>Metáfora: </a:t>
-            </a:r>
-            <a:pPr indent="0" marL="0">
-              <a:spcAft>
-                <a:spcPts val="800"/>
-              </a:spcAft>
-              <a:buNone/>
-            </a:pPr>
-            <a:r>
-              <a:rPr lang="en-US" sz="1400" dirty="0">
-                <a:solidFill>
-                  <a:schemeClr val="tx1"/>
-                </a:solidFill>
-              </a:rPr>
-              <a:t>la torre de control de un aeropuerto.</a:t>
-            </a:r>
-            <a:endParaRPr lang="en-US" sz="1400" dirty="0"/>
-          </a:p>
-          <a:p>
-            <a:pPr indent="0" marL="0">
-              <a:spcAft>
-                <a:spcPts val="800"/>
-              </a:spcAft>
-              <a:buNone/>
-            </a:pPr>
-            <a:r>
-              <a:rPr lang="en-US" sz="1400" b="1" dirty="0">
-                <a:solidFill>
-                  <a:schemeClr val="tx2"/>
-                </a:solidFill>
-              </a:rPr>
-              <a:t>Sirve para: </a:t>
-            </a:r>
-            <a:pPr indent="0" marL="0">
-              <a:spcAft>
-                <a:spcPts val="800"/>
-              </a:spcAft>
-              <a:buNone/>
-            </a:pPr>
-            <a:r>
-              <a:rPr lang="en-US" sz="1400" dirty="0">
-                <a:solidFill>
-                  <a:schemeClr val="tx1"/>
-                </a:solidFill>
-              </a:rPr>
-              <a:t>evitar una maraña de dependencias y coordinar en un solo lugar.</a:t>
-            </a:r>
-            <a:endParaRPr lang="en-US" sz="1400" dirty="0"/>
-          </a:p>
-          <a:p>
-            <a:pPr indent="0" marL="0">
-              <a:spcAft>
-                <a:spcPts val="800"/>
-              </a:spcAft>
-              <a:buNone/>
-            </a:pPr>
-            <a:r>
-              <a:rPr lang="en-US" sz="1400" b="1" dirty="0">
-                <a:solidFill>
-                  <a:schemeClr val="tx2"/>
-                </a:solidFill>
-              </a:rPr>
               <a:t>En SOA: </a:t>
             </a:r>
-            <a:pPr indent="0" marL="0">
-              <a:spcAft>
-                <a:spcPts val="800"/>
-              </a:spcAft>
-              <a:buNone/>
-            </a:pPr>
             <a:r>
               <a:rPr lang="en-US" sz="1400" dirty="0">
                 <a:solidFill>
@@ -4054,7 +3788,7 @@
           </a:prstGeom>
           <a:extLst>
             <a:ext uri="{C572A759-6A51-4108-AA02-DFA0A04FC94B}">
-              <ma14:wrappingTextBoxFlag xmlns:ma14="http://schemas.microsoft.com/office/mac/drawingml/2011/main" val="0"/>
+              <ma14:wrappingTextBoxFlag xmlns:ma14="http://schemas.microsoft.com/office/mac/drawingml/2011/main" xmlns="" val="0"/>
             </a:ext>
           </a:extLst>
         </p:spPr>
@@ -4072,7 +3806,7 @@
           <a:p>
             <a:pPr algn="l"/>
             <a:fld id="{F7021451-1387-4CA6-816F-3879F97B5CBC}" type="slidenum">
-              <a:rPr b="0" lang="en-US"/>
+              <a:rPr lang="en-US" b="0"/>
               <a:t>6</a:t>
             </a:fld>
             <a:endParaRPr lang="en-US"/>
@@ -4107,9 +3841,11 @@
       <p:sp>
         <p:nvSpPr>
           <p:cNvPr id="2" name="Text 0"/>
-          <p:cNvSpPr/>
+          <p:cNvSpPr>
+            <a:spLocks noGrp="1"/>
+          </p:cNvSpPr>
           <p:nvPr>
-            <p:ph idx="100" type="title" hasCustomPrompt="1"/>
+            <p:ph type="title" idx="100" hasCustomPrompt="1"/>
           </p:nvPr>
         </p:nvSpPr>
         <p:spPr>
@@ -4127,7 +3863,7 @@
           <a:bodyPr wrap="square" lIns="0" tIns="0" rIns="0" bIns="0" rtlCol="0" anchor="ctr"/>
           <a:lstStyle/>
           <a:p>
-            <a:pPr algn="l" indent="0" marL="0">
+            <a:pPr marL="0" indent="0" algn="l">
               <a:buNone/>
             </a:pPr>
             <a:r>
@@ -4163,7 +3899,7 @@
           <a:bodyPr wrap="square" lIns="0" tIns="0" rIns="0" bIns="0" rtlCol="0" anchor="t"/>
           <a:lstStyle/>
           <a:p>
-            <a:pPr indent="0" marL="0">
+            <a:pPr marL="0" indent="0">
               <a:buNone/>
             </a:pPr>
             <a:r>
@@ -4199,7 +3935,7 @@
           <a:bodyPr wrap="square" lIns="0" tIns="0" rIns="0" bIns="0" rtlCol="0" anchor="t"/>
           <a:lstStyle/>
           <a:p>
-            <a:pPr indent="0" marL="0">
+            <a:pPr marL="0" indent="0">
               <a:buNone/>
             </a:pPr>
             <a:r>
@@ -4236,6 +3972,13 @@
             <a:prstDash val="solid"/>
           </a:ln>
         </p:spPr>
+        <p:txBody>
+          <a:bodyPr/>
+          <a:lstStyle/>
+          <a:p>
+            <a:endParaRPr lang="es-419"/>
+          </a:p>
+        </p:txBody>
       </p:sp>
       <p:sp>
         <p:nvSpPr>
@@ -4258,7 +4001,7 @@
           <a:bodyPr wrap="square" lIns="0" tIns="0" rIns="0" bIns="0" rtlCol="0" anchor="t"/>
           <a:lstStyle/>
           <a:p>
-            <a:pPr indent="0" marL="0">
+            <a:pPr marL="0" indent="0">
               <a:spcAft>
                 <a:spcPts val="500"/>
               </a:spcAft>
@@ -4272,30 +4015,24 @@
               </a:rPr>
               <a:t>Componentes: </a:t>
             </a:r>
-            <a:pPr indent="0" marL="0">
+            <a:r>
+              <a:rPr lang="en-US" sz="1300" dirty="0">
+                <a:solidFill>
+                  <a:schemeClr val="tx1"/>
+                </a:solidFill>
+              </a:rPr>
+              <a:t>Subject, Observer, subscribe(), unsubscribe(), notify() y update().</a:t>
+            </a:r>
+            <a:endParaRPr lang="en-US" sz="1300" dirty="0"/>
+          </a:p>
+          <a:p>
+            <a:pPr marL="0" indent="0">
               <a:spcAft>
                 <a:spcPts val="500"/>
               </a:spcAft>
               <a:buNone/>
             </a:pPr>
             <a:r>
-              <a:rPr lang="en-US" sz="1300" dirty="0">
-                <a:solidFill>
-                  <a:schemeClr val="tx1"/>
-                </a:solidFill>
-              </a:rPr>
-              <a:t>Subject, Observer, subscribe(), unsubscribe(), notify() y update().</a:t>
-            </a:r>
-            <a:endParaRPr lang="en-US" sz="1300" dirty="0"/>
-          </a:p>
-          <a:p>
-            <a:pPr indent="0" marL="0">
-              <a:spcAft>
-                <a:spcPts val="500"/>
-              </a:spcAft>
-              <a:buNone/>
-            </a:pPr>
-            <a:r>
               <a:rPr lang="en-US" sz="1300" b="1" dirty="0">
                 <a:solidFill>
                   <a:schemeClr val="tx2"/>
@@ -4303,12 +4040,6 @@
               </a:rPr>
               <a:t>Por dentro: </a:t>
             </a:r>
-            <a:pPr indent="0" marL="0">
-              <a:spcAft>
-                <a:spcPts val="500"/>
-              </a:spcAft>
-              <a:buNone/>
-            </a:pPr>
             <a:r>
               <a:rPr lang="en-US" sz="1300" dirty="0">
                 <a:solidFill>
@@ -4326,7 +4057,7 @@
               </a:spcAft>
               <a:buSzPct val="100000"/>
               <a:buFont typeface="+mj-lt"/>
-              <a:buAutoNum type="arabicPeriod" startAt="1"/>
+              <a:buAutoNum type="arabicPeriod"/>
             </a:pPr>
             <a:r>
               <a:rPr lang="en-US" sz="1300" dirty="0">
@@ -4345,7 +4076,7 @@
               </a:spcAft>
               <a:buSzPct val="100000"/>
               <a:buFont typeface="+mj-lt"/>
-              <a:buAutoNum type="arabicPeriod" startAt="1"/>
+              <a:buAutoNum type="arabicPeriod"/>
             </a:pPr>
             <a:r>
               <a:rPr lang="en-US" sz="1300" dirty="0">
@@ -4364,7 +4095,7 @@
               </a:spcAft>
               <a:buSzPct val="100000"/>
               <a:buFont typeface="+mj-lt"/>
-              <a:buAutoNum type="arabicPeriod" startAt="1"/>
+              <a:buAutoNum type="arabicPeriod"/>
             </a:pPr>
             <a:r>
               <a:rPr lang="en-US" sz="1300" dirty="0">
@@ -4377,7 +4108,7 @@
             <a:endParaRPr lang="en-US" sz="1300" dirty="0"/>
           </a:p>
           <a:p>
-            <a:pPr indent="0" marL="0">
+            <a:pPr marL="0" indent="0">
               <a:spcAft>
                 <a:spcPts val="500"/>
               </a:spcAft>
@@ -4386,7 +4117,7 @@
             <a:endParaRPr lang="en-US" sz="1300" dirty="0"/>
           </a:p>
           <a:p>
-            <a:pPr indent="0" marL="0">
+            <a:pPr marL="0" indent="0">
               <a:spcAft>
                 <a:spcPts val="500"/>
               </a:spcAft>
@@ -4400,46 +4131,65 @@
               </a:rPr>
               <a:t>En SOA: </a:t>
             </a:r>
-            <a:pPr indent="0" marL="0">
+            <a:r>
+              <a:rPr lang="en-US" sz="1300" dirty="0">
+                <a:solidFill>
+                  <a:schemeClr val="tx1"/>
+                </a:solidFill>
+              </a:rPr>
+              <a:t>el broker hace de lista y entrega el evento a cada suscriptor.</a:t>
+            </a:r>
+            <a:endParaRPr lang="en-US" sz="1300" dirty="0"/>
+          </a:p>
+        </p:txBody>
+      </p:sp>
+      <p:sp>
+        <p:nvSpPr>
+          <p:cNvPr id="7" name="Text 5"/>
+          <p:cNvSpPr txBox="1"/>
+          <p:nvPr/>
+        </p:nvSpPr>
+        <p:spPr>
+          <a:xfrm>
+            <a:off x="4846320" y="1508760"/>
+            <a:ext cx="3749040" cy="3108960"/>
+          </a:xfrm>
+          <a:prstGeom prst="rect">
+            <a:avLst/>
+          </a:prstGeom>
+          <a:noFill/>
+          <a:ln/>
+        </p:spPr>
+        <p:txBody>
+          <a:bodyPr wrap="square" lIns="0" tIns="0" rIns="0" bIns="0" rtlCol="0" anchor="t"/>
+          <a:lstStyle/>
+          <a:p>
+            <a:pPr marL="0" indent="0">
               <a:spcAft>
                 <a:spcPts val="500"/>
               </a:spcAft>
               <a:buNone/>
             </a:pPr>
             <a:r>
+              <a:rPr lang="en-US" sz="1300" b="1" dirty="0">
+                <a:solidFill>
+                  <a:schemeClr val="tx2"/>
+                </a:solidFill>
+              </a:rPr>
+              <a:t>Componentes: </a:t>
+            </a:r>
+            <a:r>
               <a:rPr lang="en-US" sz="1300" dirty="0">
                 <a:solidFill>
                   <a:schemeClr val="tx1"/>
                 </a:solidFill>
               </a:rPr>
-              <a:t>el broker hace de lista y entrega el evento a cada suscriptor.</a:t>
+              <a:t>interfaz Mediator, mediador concreto y Colleagues.</a:t>
             </a:r>
             <a:endParaRPr lang="en-US" sz="1300" dirty="0"/>
           </a:p>
-        </p:txBody>
-      </p:sp>
-      <p:sp>
-        <p:nvSpPr>
-          <p:cNvPr id="7" name="Text 5"/>
-          <p:cNvSpPr txBox="1"/>
-          <p:nvPr/>
-        </p:nvSpPr>
-        <p:spPr>
-          <a:xfrm>
-            <a:off x="4846320" y="1508760"/>
-            <a:ext cx="3749040" cy="3108960"/>
-          </a:xfrm>
-          <a:prstGeom prst="rect">
-            <a:avLst/>
-          </a:prstGeom>
-          <a:noFill/>
-          <a:ln/>
-        </p:spPr>
-        <p:txBody>
-          <a:bodyPr wrap="square" lIns="0" tIns="0" rIns="0" bIns="0" rtlCol="0" anchor="t"/>
-          <a:lstStyle/>
-          <a:p>
-            <a:pPr indent="0" marL="0">
+          <a:p>
+            <a:pPr marL="0" indent="0">
               <a:spcAft>
                 <a:spcPts val="500"/>
               </a:spcAft>
@@ -4451,45 +4201,8 @@
                   <a:schemeClr val="tx2"/>
                 </a:solidFill>
               </a:rPr>
-              <a:t>Componentes: </a:t>
-            </a:r>
-            <a:pPr indent="0" marL="0">
-              <a:spcAft>
-                <a:spcPts val="500"/>
-              </a:spcAft>
-              <a:buNone/>
-            </a:pPr>
-            <a:r>
-              <a:rPr lang="en-US" sz="1300" dirty="0">
-                <a:solidFill>
-                  <a:schemeClr val="tx1"/>
-                </a:solidFill>
-              </a:rPr>
-              <a:t>interfaz Mediator, mediador concreto y Colleagues.</a:t>
-            </a:r>
-            <a:endParaRPr lang="en-US" sz="1300" dirty="0"/>
-          </a:p>
-          <a:p>
-            <a:pPr indent="0" marL="0">
-              <a:spcAft>
-                <a:spcPts val="500"/>
-              </a:spcAft>
-              <a:buNone/>
-            </a:pPr>
-            <a:r>
-              <a:rPr lang="en-US" sz="1300" b="1" dirty="0">
-                <a:solidFill>
-                  <a:schemeClr val="tx2"/>
-                </a:solidFill>
-              </a:rPr>
               <a:t>Por dentro: </a:t>
             </a:r>
-            <a:pPr indent="0" marL="0">
-              <a:spcAft>
-                <a:spcPts val="500"/>
-              </a:spcAft>
-              <a:buNone/>
-            </a:pPr>
             <a:r>
               <a:rPr lang="en-US" sz="1300" dirty="0">
                 <a:solidFill>
@@ -4507,7 +4220,7 @@
               </a:spcAft>
               <a:buSzPct val="100000"/>
               <a:buFont typeface="+mj-lt"/>
-              <a:buAutoNum type="arabicPeriod" startAt="1"/>
+              <a:buAutoNum type="arabicPeriod"/>
             </a:pPr>
             <a:r>
               <a:rPr lang="en-US" sz="1300" dirty="0">
@@ -4526,7 +4239,7 @@
               </a:spcAft>
               <a:buSzPct val="100000"/>
               <a:buFont typeface="+mj-lt"/>
-              <a:buAutoNum type="arabicPeriod" startAt="1"/>
+              <a:buAutoNum type="arabicPeriod"/>
             </a:pPr>
             <a:r>
               <a:rPr lang="en-US" sz="1300" dirty="0">
@@ -4545,7 +4258,7 @@
               </a:spcAft>
               <a:buSzPct val="100000"/>
               <a:buFont typeface="+mj-lt"/>
-              <a:buAutoNum type="arabicPeriod" startAt="1"/>
+              <a:buAutoNum type="arabicPeriod"/>
             </a:pPr>
             <a:r>
               <a:rPr lang="en-US" sz="1300" dirty="0">
@@ -4558,7 +4271,7 @@
             <a:endParaRPr lang="en-US" sz="1300" dirty="0"/>
           </a:p>
           <a:p>
-            <a:pPr indent="0" marL="0">
+            <a:pPr marL="0" indent="0">
               <a:spcAft>
                 <a:spcPts val="500"/>
               </a:spcAft>
@@ -4567,7 +4280,7 @@
             <a:endParaRPr lang="en-US" sz="1300" dirty="0"/>
           </a:p>
           <a:p>
-            <a:pPr indent="0" marL="0">
+            <a:pPr marL="0" indent="0">
               <a:spcAft>
                 <a:spcPts val="500"/>
               </a:spcAft>
@@ -4581,12 +4294,6 @@
               </a:rPr>
               <a:t>En SOA: </a:t>
             </a:r>
-            <a:pPr indent="0" marL="0">
-              <a:spcAft>
-                <a:spcPts val="500"/>
-              </a:spcAft>
-              <a:buNone/>
-            </a:pPr>
             <a:r>
               <a:rPr lang="en-US" sz="1300" dirty="0">
                 <a:solidFill>
@@ -4619,7 +4326,7 @@
           </a:prstGeom>
           <a:extLst>
             <a:ext uri="{C572A759-6A51-4108-AA02-DFA0A04FC94B}">
-              <ma14:wrappingTextBoxFlag xmlns:ma14="http://schemas.microsoft.com/office/mac/drawingml/2011/main" val="0"/>
+              <ma14:wrappingTextBoxFlag xmlns:ma14="http://schemas.microsoft.com/office/mac/drawingml/2011/main" xmlns="" val="0"/>
             </a:ext>
           </a:extLst>
         </p:spPr>
@@ -4637,7 +4344,7 @@
           <a:p>
             <a:pPr algn="l"/>
             <a:fld id="{F7021451-1387-4CA6-816F-3879F97B5CBC}" type="slidenum">
-              <a:rPr b="0" lang="en-US"/>
+              <a:rPr lang="en-US" b="0"/>
               <a:t>7</a:t>
             </a:fld>
             <a:endParaRPr lang="en-US"/>
@@ -4672,9 +4379,11 @@
       <p:sp>
         <p:nvSpPr>
           <p:cNvPr id="2" name="Text 0"/>
-          <p:cNvSpPr/>
+          <p:cNvSpPr>
+            <a:spLocks noGrp="1"/>
+          </p:cNvSpPr>
           <p:nvPr>
-            <p:ph idx="100" type="title" hasCustomPrompt="1"/>
+            <p:ph type="title" idx="100" hasCustomPrompt="1"/>
           </p:nvPr>
         </p:nvSpPr>
         <p:spPr>
@@ -4692,7 +4401,7 @@
           <a:bodyPr wrap="square" lIns="0" tIns="0" rIns="0" bIns="0" rtlCol="0" anchor="ctr"/>
           <a:lstStyle/>
           <a:p>
-            <a:pPr algn="l" indent="0" marL="0">
+            <a:pPr marL="0" indent="0" algn="l">
               <a:buNone/>
             </a:pPr>
             <a:r>
@@ -4728,7 +4437,7 @@
           <a:bodyPr wrap="square" lIns="0" tIns="0" rIns="0" bIns="0" rtlCol="0" anchor="t"/>
           <a:lstStyle/>
           <a:p>
-            <a:pPr indent="0" marL="0">
+            <a:pPr marL="0" indent="0">
               <a:buNone/>
             </a:pPr>
             <a:r>
@@ -4764,7 +4473,7 @@
           <a:bodyPr wrap="square" lIns="0" tIns="0" rIns="0" bIns="0" rtlCol="0" anchor="t"/>
           <a:lstStyle/>
           <a:p>
-            <a:pPr indent="0" marL="0">
+            <a:pPr marL="0" indent="0">
               <a:buNone/>
             </a:pPr>
             <a:r>
@@ -4801,6 +4510,13 @@
             <a:prstDash val="solid"/>
           </a:ln>
         </p:spPr>
+        <p:txBody>
+          <a:bodyPr/>
+          <a:lstStyle/>
+          <a:p>
+            <a:endParaRPr lang="es-419"/>
+          </a:p>
+        </p:txBody>
       </p:sp>
       <p:sp>
         <p:nvSpPr>
@@ -4826,6 +4542,13 @@
             <a:prstDash val="solid"/>
           </a:ln>
         </p:spPr>
+        <p:txBody>
+          <a:bodyPr/>
+          <a:lstStyle/>
+          <a:p>
+            <a:endParaRPr lang="es-419"/>
+          </a:p>
+        </p:txBody>
       </p:sp>
       <p:sp>
         <p:nvSpPr>
@@ -4848,7 +4571,7 @@
           <a:bodyPr wrap="square" lIns="0" tIns="0" rIns="0" bIns="0" rtlCol="0" anchor="ctr"/>
           <a:lstStyle/>
           <a:p>
-            <a:pPr algn="ctr" indent="0" marL="0">
+            <a:pPr marL="0" indent="0" algn="ctr">
               <a:buNone/>
             </a:pPr>
             <a:r>
@@ -4862,7 +4585,7 @@
             <a:endParaRPr lang="en-US" sz="1200" dirty="0"/>
           </a:p>
           <a:p>
-            <a:pPr algn="ctr" indent="0" marL="0">
+            <a:pPr marL="0" indent="0" algn="ctr">
               <a:buNone/>
             </a:pPr>
             <a:r>
@@ -4901,6 +4624,13 @@
             <a:prstDash val="solid"/>
           </a:ln>
         </p:spPr>
+        <p:txBody>
+          <a:bodyPr/>
+          <a:lstStyle/>
+          <a:p>
+            <a:endParaRPr lang="es-419"/>
+          </a:p>
+        </p:txBody>
       </p:sp>
       <p:sp>
         <p:nvSpPr>
@@ -4923,7 +4653,7 @@
           <a:bodyPr wrap="square" lIns="0" tIns="0" rIns="0" bIns="0" rtlCol="0" anchor="ctr"/>
           <a:lstStyle/>
           <a:p>
-            <a:pPr algn="ctr" indent="0" marL="0">
+            <a:pPr marL="0" indent="0" algn="ctr">
               <a:buNone/>
             </a:pPr>
             <a:r>
@@ -4962,6 +4692,13 @@
             <a:prstDash val="solid"/>
           </a:ln>
         </p:spPr>
+        <p:txBody>
+          <a:bodyPr/>
+          <a:lstStyle/>
+          <a:p>
+            <a:endParaRPr lang="es-419"/>
+          </a:p>
+        </p:txBody>
       </p:sp>
       <p:sp>
         <p:nvSpPr>
@@ -4984,7 +4721,7 @@
           <a:bodyPr wrap="square" lIns="0" tIns="0" rIns="0" bIns="0" rtlCol="0" anchor="ctr"/>
           <a:lstStyle/>
           <a:p>
-            <a:pPr algn="ctr" indent="0" marL="0">
+            <a:pPr marL="0" indent="0" algn="ctr">
               <a:buNone/>
             </a:pPr>
             <a:r>
@@ -5023,6 +4760,13 @@
             <a:prstDash val="solid"/>
           </a:ln>
         </p:spPr>
+        <p:txBody>
+          <a:bodyPr/>
+          <a:lstStyle/>
+          <a:p>
+            <a:endParaRPr lang="es-419"/>
+          </a:p>
+        </p:txBody>
       </p:sp>
       <p:sp>
         <p:nvSpPr>
@@ -5045,7 +4789,7 @@
           <a:bodyPr wrap="square" lIns="0" tIns="0" rIns="0" bIns="0" rtlCol="0" anchor="ctr"/>
           <a:lstStyle/>
           <a:p>
-            <a:pPr algn="ctr" indent="0" marL="0">
+            <a:pPr marL="0" indent="0" algn="ctr">
               <a:buNone/>
             </a:pPr>
             <a:r>
@@ -5083,6 +4827,13 @@
             <a:tailEnd type="triangle"/>
           </a:ln>
         </p:spPr>
+        <p:txBody>
+          <a:bodyPr/>
+          <a:lstStyle/>
+          <a:p>
+            <a:endParaRPr lang="es-419"/>
+          </a:p>
+        </p:txBody>
       </p:sp>
       <p:sp>
         <p:nvSpPr>
@@ -5107,6 +4858,13 @@
             <a:tailEnd type="triangle"/>
           </a:ln>
         </p:spPr>
+        <p:txBody>
+          <a:bodyPr/>
+          <a:lstStyle/>
+          <a:p>
+            <a:endParaRPr lang="es-419"/>
+          </a:p>
+        </p:txBody>
       </p:sp>
       <p:sp>
         <p:nvSpPr>
@@ -5131,6 +4889,13 @@
             <a:tailEnd type="triangle"/>
           </a:ln>
         </p:spPr>
+        <p:txBody>
+          <a:bodyPr/>
+          <a:lstStyle/>
+          <a:p>
+            <a:endParaRPr lang="es-419"/>
+          </a:p>
+        </p:txBody>
       </p:sp>
       <p:sp>
         <p:nvSpPr>
@@ -5156,6 +4921,13 @@
             <a:prstDash val="solid"/>
           </a:ln>
         </p:spPr>
+        <p:txBody>
+          <a:bodyPr/>
+          <a:lstStyle/>
+          <a:p>
+            <a:endParaRPr lang="es-419"/>
+          </a:p>
+        </p:txBody>
       </p:sp>
       <p:sp>
         <p:nvSpPr>
@@ -5178,7 +4950,7 @@
           <a:bodyPr wrap="square" lIns="0" tIns="0" rIns="0" bIns="0" rtlCol="0" anchor="ctr"/>
           <a:lstStyle/>
           <a:p>
-            <a:pPr algn="ctr" indent="0" marL="0">
+            <a:pPr marL="0" indent="0" algn="ctr">
               <a:buNone/>
             </a:pPr>
             <a:r>
@@ -5217,6 +4989,13 @@
             <a:prstDash val="solid"/>
           </a:ln>
         </p:spPr>
+        <p:txBody>
+          <a:bodyPr/>
+          <a:lstStyle/>
+          <a:p>
+            <a:endParaRPr lang="es-419"/>
+          </a:p>
+        </p:txBody>
       </p:sp>
       <p:sp>
         <p:nvSpPr>
@@ -5239,7 +5018,7 @@
           <a:bodyPr wrap="square" lIns="0" tIns="0" rIns="0" bIns="0" rtlCol="0" anchor="ctr"/>
           <a:lstStyle/>
           <a:p>
-            <a:pPr algn="ctr" indent="0" marL="0">
+            <a:pPr marL="0" indent="0" algn="ctr">
               <a:buNone/>
             </a:pPr>
             <a:r>
@@ -5278,6 +5057,13 @@
             <a:prstDash val="solid"/>
           </a:ln>
         </p:spPr>
+        <p:txBody>
+          <a:bodyPr/>
+          <a:lstStyle/>
+          <a:p>
+            <a:endParaRPr lang="es-419"/>
+          </a:p>
+        </p:txBody>
       </p:sp>
       <p:sp>
         <p:nvSpPr>
@@ -5300,7 +5086,7 @@
           <a:bodyPr wrap="square" lIns="0" tIns="0" rIns="0" bIns="0" rtlCol="0" anchor="ctr"/>
           <a:lstStyle/>
           <a:p>
-            <a:pPr algn="ctr" indent="0" marL="0">
+            <a:pPr marL="0" indent="0" algn="ctr">
               <a:buNone/>
             </a:pPr>
             <a:r>
@@ -5339,6 +5125,13 @@
             <a:prstDash val="solid"/>
           </a:ln>
         </p:spPr>
+        <p:txBody>
+          <a:bodyPr/>
+          <a:lstStyle/>
+          <a:p>
+            <a:endParaRPr lang="es-419"/>
+          </a:p>
+        </p:txBody>
       </p:sp>
       <p:sp>
         <p:nvSpPr>
@@ -5361,7 +5154,7 @@
           <a:bodyPr wrap="square" lIns="0" tIns="0" rIns="0" bIns="0" rtlCol="0" anchor="ctr"/>
           <a:lstStyle/>
           <a:p>
-            <a:pPr algn="ctr" indent="0" marL="0">
+            <a:pPr marL="0" indent="0" algn="ctr">
               <a:buNone/>
             </a:pPr>
             <a:r>
@@ -5400,6 +5193,13 @@
             <a:tailEnd type="triangle"/>
           </a:ln>
         </p:spPr>
+        <p:txBody>
+          <a:bodyPr/>
+          <a:lstStyle/>
+          <a:p>
+            <a:endParaRPr lang="es-419"/>
+          </a:p>
+        </p:txBody>
       </p:sp>
       <p:sp>
         <p:nvSpPr>
@@ -5425,6 +5225,13 @@
             <a:tailEnd type="triangle"/>
           </a:ln>
         </p:spPr>
+        <p:txBody>
+          <a:bodyPr/>
+          <a:lstStyle/>
+          <a:p>
+            <a:endParaRPr lang="es-419"/>
+          </a:p>
+        </p:txBody>
       </p:sp>
       <p:sp>
         <p:nvSpPr>
@@ -5450,6 +5257,13 @@
             <a:tailEnd type="triangle"/>
           </a:ln>
         </p:spPr>
+        <p:txBody>
+          <a:bodyPr/>
+          <a:lstStyle/>
+          <a:p>
+            <a:endParaRPr lang="es-419"/>
+          </a:p>
+        </p:txBody>
       </p:sp>
       <p:sp>
         <p:nvSpPr>
@@ -5472,7 +5286,7 @@
           <a:bodyPr wrap="square" lIns="0" tIns="0" rIns="0" bIns="0" rtlCol="0" anchor="t"/>
           <a:lstStyle/>
           <a:p>
-            <a:pPr indent="0" marL="0">
+            <a:pPr marL="0" indent="0">
               <a:buNone/>
             </a:pPr>
             <a:r>
@@ -5508,7 +5322,7 @@
           <a:bodyPr wrap="square" lIns="0" tIns="0" rIns="0" bIns="0" rtlCol="0" anchor="t"/>
           <a:lstStyle/>
           <a:p>
-            <a:pPr indent="0" marL="0">
+            <a:pPr marL="0" indent="0">
               <a:buNone/>
             </a:pPr>
             <a:r>
@@ -5525,7 +5339,7 @@
       </p:sp>
       <p:sp>
         <p:nvSpPr>
-          <p:cNvPr id="25" name="Slide Number Placeholder 0"/>
+          <p:cNvPr id="30" name="Slide Number Placeholder 0"/>
           <p:cNvSpPr>
             <a:spLocks noGrp="1"/>
           </p:cNvSpPr>
@@ -5543,7 +5357,7 @@
           </a:prstGeom>
           <a:extLst>
             <a:ext uri="{C572A759-6A51-4108-AA02-DFA0A04FC94B}">
-              <ma14:wrappingTextBoxFlag xmlns:ma14="http://schemas.microsoft.com/office/mac/drawingml/2011/main" val="0"/>
+              <ma14:wrappingTextBoxFlag xmlns:ma14="http://schemas.microsoft.com/office/mac/drawingml/2011/main" xmlns="" val="0"/>
             </a:ext>
           </a:extLst>
         </p:spPr>
@@ -5561,7 +5375,7 @@
           <a:p>
             <a:pPr algn="l"/>
             <a:fld id="{F7021451-1387-4CA6-816F-3879F97B5CBC}" type="slidenum">
-              <a:rPr b="0" lang="en-US"/>
+              <a:rPr lang="en-US" b="0"/>
               <a:t>8</a:t>
             </a:fld>
             <a:endParaRPr lang="en-US"/>
@@ -5869,4 +5683,319 @@
     </a:ext>
   </a:extLst>
 </a:theme>
+</file>
+
+<file path=ppt/theme/theme2.xml><?xml version="1.0" encoding="utf-8"?>
+<a:theme xmlns:a="http://schemas.openxmlformats.org/drawingml/2006/main" name="Tema de Office">
+  <a:themeElements>
+    <a:clrScheme name="Office">
+      <a:dk1>
+        <a:sysClr val="windowText" lastClr="000000"/>
+      </a:dk1>
+      <a:lt1>
+        <a:sysClr val="window" lastClr="FFFFFF"/>
+      </a:lt1>
+      <a:dk2>
+        <a:srgbClr val="0E2841"/>
+      </a:dk2>
+      <a:lt2>
+        <a:srgbClr val="E8E8E8"/>
+      </a:lt2>
+      <a:accent1>
+        <a:srgbClr val="156082"/>
+      </a:accent1>
+      <a:accent2>
+        <a:srgbClr val="E97132"/>
+      </a:accent2>
+      <a:accent3>
+        <a:srgbClr val="196B24"/>
+      </a:accent3>
+      <a:accent4>
+        <a:srgbClr val="0F9ED5"/>
+      </a:accent4>
+      <a:accent5>
+        <a:srgbClr val="A02B93"/>
+      </a:accent5>
+      <a:accent6>
+        <a:srgbClr val="4EA72E"/>
+      </a:accent6>
+      <a:hlink>
+        <a:srgbClr val="467886"/>
+      </a:hlink>
+      <a:folHlink>
+        <a:srgbClr val="96607D"/>
+      </a:folHlink>
+    </a:clrScheme>
+    <a:fontScheme name="Office">
+      <a:majorFont>
+        <a:latin typeface="Aptos Display" panose="02110004020202020204"/>
+        <a:ea typeface=""/>
+        <a:cs typeface=""/>
+        <a:font script="Jpan" typeface="游ゴシック Light"/>
+        <a:font script="Hang" typeface="맑은 고딕"/>
+        <a:font script="Hans" typeface="等线 Light"/>
+        <a:font script="Hant" typeface="新細明體"/>
+        <a:font script="Arab" typeface="Times New Roman"/>
+        <a:font script="Hebr" typeface="Times New Roman"/>
+        <a:font script="Thai" typeface="Angsana New"/>
+        <a:font script="Ethi" typeface="Nyala"/>
+        <a:font script="Beng" typeface="Vrinda"/>
+        <a:font script="Gujr" typeface="Shruti"/>
+        <a:font script="Khmr" typeface="MoolBoran"/>
+        <a:font script="Knda" typeface="Tunga"/>
+        <a:font script="Guru" typeface="Raavi"/>
+        <a:font script="Cans" typeface="Euphemia"/>
+        <a:font script="Cher" typeface="Plantagenet Cherokee"/>
+        <a:font script="Yiii" typeface="Microsoft Yi Baiti"/>
+        <a:font script="Tibt" typeface="Microsoft Himalaya"/>
+        <a:font script="Thaa" typeface="MV Boli"/>
+        <a:font script="Deva" typeface="Mangal"/>
+        <a:font script="Telu" typeface="Gautami"/>
+        <a:font script="Taml" typeface="Latha"/>
+        <a:font script="Syrc" typeface="Estrangelo Edessa"/>
+        <a:font script="Orya" typeface="Kalinga"/>
+        <a:font script="Mlym" typeface="Kartika"/>
+        <a:font script="Laoo" typeface="DokChampa"/>
+        <a:font script="Sinh" typeface="Iskoola Pota"/>
+        <a:font script="Mong" typeface="Mongolian Baiti"/>
+        <a:font script="Viet" typeface="Times New Roman"/>
+        <a:font script="Uigh" typeface="Microsoft Uighur"/>
+        <a:font script="Geor" typeface="Sylfaen"/>
+        <a:font script="Armn" typeface="Arial"/>
+        <a:font script="Bugi" typeface="Leelawadee UI"/>
+        <a:font script="Bopo" typeface="Microsoft JhengHei"/>
+        <a:font script="Java" typeface="Javanese Text"/>
+        <a:font script="Lisu" typeface="Segoe UI"/>
+        <a:font script="Mymr" typeface="Myanmar Text"/>
+        <a:font script="Nkoo" typeface="Ebrima"/>
+        <a:font script="Olck" typeface="Nirmala UI"/>
+        <a:font script="Osma" typeface="Ebrima"/>
+        <a:font script="Phag" typeface="Phagspa"/>
+        <a:font script="Syrn" typeface="Estrangelo Edessa"/>
+        <a:font script="Syrj" typeface="Estrangelo Edessa"/>
+        <a:font script="Syre" typeface="Estrangelo Edessa"/>
+        <a:font script="Sora" typeface="Nirmala UI"/>
+        <a:font script="Tale" typeface="Microsoft Tai Le"/>
+        <a:font script="Talu" typeface="Microsoft New Tai Lue"/>
+        <a:font script="Tfng" typeface="Ebrima"/>
+      </a:majorFont>
+      <a:minorFont>
+        <a:latin typeface="Aptos" panose="02110004020202020204"/>
+        <a:ea typeface=""/>
+        <a:cs typeface=""/>
+        <a:font script="Jpan" typeface="游ゴシック"/>
+        <a:font script="Hang" typeface="맑은 고딕"/>
+        <a:font script="Hans" typeface="等线"/>
+        <a:font script="Hant" typeface="新細明體"/>
+        <a:font script="Arab" typeface="Arial"/>
+        <a:font script="Hebr" typeface="Arial"/>
+        <a:font script="Thai" typeface="Cordia New"/>
+        <a:font script="Ethi" typeface="Nyala"/>
+        <a:font script="Beng" typeface="Vrinda"/>
+        <a:font script="Gujr" typeface="Shruti"/>
+        <a:font script="Khmr" typeface="DaunPenh"/>
+        <a:font script="Knda" typeface="Tunga"/>
+        <a:font script="Guru" typeface="Raavi"/>
+        <a:font script="Cans" typeface="Euphemia"/>
+        <a:font script="Cher" typeface="Plantagenet Cherokee"/>
+        <a:font script="Yiii" typeface="Microsoft Yi Baiti"/>
+        <a:font script="Tibt" typeface="Microsoft Himalaya"/>
+        <a:font script="Thaa" typeface="MV Boli"/>
+        <a:font script="Deva" typeface="Mangal"/>
+        <a:font script="Telu" typeface="Gautami"/>
+        <a:font script="Taml" typeface="Latha"/>
+        <a:font script="Syrc" typeface="Estrangelo Edessa"/>
+        <a:font script="Orya" typeface="Kalinga"/>
+        <a:font script="Mlym" typeface="Kartika"/>
+        <a:font script="Laoo" typeface="DokChampa"/>
+        <a:font script="Sinh" typeface="Iskoola Pota"/>
+        <a:font script="Mong" typeface="Mongolian Baiti"/>
+        <a:font script="Viet" typeface="Arial"/>
+        <a:font script="Uigh" typeface="Microsoft Uighur"/>
+        <a:font script="Geor" typeface="Sylfaen"/>
+        <a:font script="Armn" typeface="Arial"/>
+        <a:font script="Bugi" typeface="Leelawadee UI"/>
+        <a:font script="Bopo" typeface="Microsoft JhengHei"/>
+        <a:font script="Java" typeface="Javanese Text"/>
+        <a:font script="Lisu" typeface="Segoe UI"/>
+        <a:font script="Mymr" typeface="Myanmar Text"/>
+        <a:font script="Nkoo" typeface="Ebrima"/>
+        <a:font script="Olck" typeface="Nirmala UI"/>
+        <a:font script="Osma" typeface="Ebrima"/>
+        <a:font script="Phag" typeface="Phagspa"/>
+        <a:font script="Syrn" typeface="Estrangelo Edessa"/>
+        <a:font script="Syrj" typeface="Estrangelo Edessa"/>
+        <a:font script="Syre" typeface="Estrangelo Edessa"/>
+        <a:font script="Sora" typeface="Nirmala UI"/>
+        <a:font script="Tale" typeface="Microsoft Tai Le"/>
+        <a:font script="Talu" typeface="Microsoft New Tai Lue"/>
+        <a:font script="Tfng" typeface="Ebrima"/>
+      </a:minorFont>
+    </a:fontScheme>
+    <a:fmtScheme name="Office">
+      <a:fillStyleLst>
+        <a:solidFill>
+          <a:schemeClr val="phClr"/>
+        </a:solidFill>
+        <a:gradFill rotWithShape="1">
+          <a:gsLst>
+            <a:gs pos="0">
+              <a:schemeClr val="phClr">
+                <a:lumMod val="110000"/>
+                <a:satMod val="105000"/>
+                <a:tint val="67000"/>
+              </a:schemeClr>
+            </a:gs>
+            <a:gs pos="50000">
+              <a:schemeClr val="phClr">
+                <a:lumMod val="105000"/>
+                <a:satMod val="103000"/>
+                <a:tint val="73000"/>
+              </a:schemeClr>
+            </a:gs>
+            <a:gs pos="100000">
+              <a:schemeClr val="phClr">
+                <a:lumMod val="105000"/>
+                <a:satMod val="109000"/>
+                <a:tint val="81000"/>
+              </a:schemeClr>
+            </a:gs>
+          </a:gsLst>
+          <a:lin ang="5400000" scaled="0"/>
+        </a:gradFill>
+        <a:gradFill rotWithShape="1">
+          <a:gsLst>
+            <a:gs pos="0">
+              <a:schemeClr val="phClr">
+                <a:satMod val="103000"/>
+                <a:lumMod val="102000"/>
+                <a:tint val="94000"/>
+              </a:schemeClr>
+            </a:gs>
+            <a:gs pos="50000">
+              <a:schemeClr val="phClr">
+                <a:satMod val="110000"/>
+                <a:lumMod val="100000"/>
+                <a:shade val="100000"/>
+              </a:schemeClr>
+            </a:gs>
+            <a:gs pos="100000">
+              <a:schemeClr val="phClr">
+                <a:lumMod val="99000"/>
+                <a:satMod val="120000"/>
+                <a:shade val="78000"/>
+              </a:schemeClr>
+            </a:gs>
+          </a:gsLst>
+          <a:lin ang="5400000" scaled="0"/>
+        </a:gradFill>
+      </a:fillStyleLst>
+      <a:lnStyleLst>
+        <a:ln w="12700" cap="flat" cmpd="sng" algn="ctr">
+          <a:solidFill>
+            <a:schemeClr val="phClr"/>
+          </a:solidFill>
+          <a:prstDash val="solid"/>
+          <a:miter lim="800000"/>
+        </a:ln>
+        <a:ln w="19050" cap="flat" cmpd="sng" algn="ctr">
+          <a:solidFill>
+            <a:schemeClr val="phClr"/>
+          </a:solidFill>
+          <a:prstDash val="solid"/>
+          <a:miter lim="800000"/>
+        </a:ln>
+        <a:ln w="25400" cap="flat" cmpd="sng" algn="ctr">
+          <a:solidFill>
+            <a:schemeClr val="phClr"/>
+          </a:solidFill>
+          <a:prstDash val="solid"/>
+          <a:miter lim="800000"/>
+        </a:ln>
+      </a:lnStyleLst>
+      <a:effectStyleLst>
+        <a:effectStyle>
+          <a:effectLst/>
+        </a:effectStyle>
+        <a:effectStyle>
+          <a:effectLst/>
+        </a:effectStyle>
+        <a:effectStyle>
+          <a:effectLst>
+            <a:outerShdw blurRad="57150" dist="19050" dir="5400000" algn="ctr" rotWithShape="0">
+              <a:srgbClr val="000000">
+                <a:alpha val="63000"/>
+              </a:srgbClr>
+            </a:outerShdw>
+          </a:effectLst>
+        </a:effectStyle>
+      </a:effectStyleLst>
+      <a:bgFillStyleLst>
+        <a:solidFill>
+          <a:schemeClr val="phClr"/>
+        </a:solidFill>
+        <a:solidFill>
+          <a:schemeClr val="phClr">
+            <a:tint val="95000"/>
+            <a:satMod val="170000"/>
+          </a:schemeClr>
+        </a:solidFill>
+        <a:gradFill rotWithShape="1">
+          <a:gsLst>
+            <a:gs pos="0">
+              <a:schemeClr val="phClr">
+                <a:tint val="93000"/>
+                <a:satMod val="150000"/>
+                <a:shade val="98000"/>
+                <a:lumMod val="102000"/>
+              </a:schemeClr>
+            </a:gs>
+            <a:gs pos="50000">
+              <a:schemeClr val="phClr">
+                <a:tint val="98000"/>
+                <a:satMod val="130000"/>
+                <a:shade val="90000"/>
+                <a:lumMod val="103000"/>
+              </a:schemeClr>
+            </a:gs>
+            <a:gs pos="100000">
+              <a:schemeClr val="phClr">
+                <a:shade val="63000"/>
+                <a:satMod val="120000"/>
+              </a:schemeClr>
+            </a:gs>
+          </a:gsLst>
+          <a:lin ang="5400000" scaled="0"/>
+        </a:gradFill>
+      </a:bgFillStyleLst>
+    </a:fmtScheme>
+  </a:themeElements>
+  <a:objectDefaults>
+    <a:lnDef>
+      <a:spPr/>
+      <a:bodyPr/>
+      <a:lstStyle/>
+      <a:style>
+        <a:lnRef idx="2">
+          <a:schemeClr val="accent1"/>
+        </a:lnRef>
+        <a:fillRef idx="0">
+          <a:schemeClr val="accent1"/>
+        </a:fillRef>
+        <a:effectRef idx="1">
+          <a:schemeClr val="accent1"/>
+        </a:effectRef>
+        <a:fontRef idx="minor">
+          <a:schemeClr val="tx1"/>
+        </a:fontRef>
+      </a:style>
+    </a:lnDef>
+  </a:objectDefaults>
+  <a:extraClrSchemeLst/>
+  <a:extLst>
+    <a:ext uri="{05A4C25C-085E-4340-85A3-A5531E510DB2}">
+      <thm15:themeFamily xmlns:thm15="http://schemas.microsoft.com/office/thememl/2012/main" name="Office Theme" id="{2E142A2C-CD16-42D6-873A-C26D2A0506FA}" vid="{1BDDFF52-6CD6-40A5-AB3C-68EB2F1E4D0A}"/>
+    </a:ext>
+  </a:extLst>
+</a:theme>
 </file>
</xml_diff>